<commit_message>
docs: reinstate biomass CHP as primary energy; correct EV adoption framing
Biomass CHP from sugi thinnings (electricity primary, heat secondary) is
now the lead energy narrative across all 18 documents and OpenProject.
Solar panels and EV charging are reframed as complementary systems.

Also corrects overstated EV adoption claims: replaces "most Japanese cars
will be electric in 10 years" with accurate projections (10–15% of total
fleet by 2036, 30–40% of new car sales by mid-2030s; source: evsmart.net).

OpenProject updated: WP 57, 71, 85 (EN) and WP 164, 177, 190 (JP) —
biomass CHP reordered as primary item in feasibility scope and task subjects.

PowerPoint decks (EN + JP) updated on Slide 3 with same corrections.

Co-Authored-By: Claude Sonnet 4.6 <noreply@anthropic.com>
</commit_message>
<xml_diff>
--- a/Mitsue Project Presentation.pptx
+++ b/Mitsue Project Presentation.pptx
@@ -132,7 +132,18 @@
                 <a:uFillTx/>
                 <a:latin typeface="Arial"/>
               </a:rPr>
-              <a:t>Click to edit the notes format</a:t>
+              <a:t>Click to edit the </a:t>
+            </a:r>
+            <a:r>
+              <a:rPr lang="en-US" sz="2000" b="0" u="none" strike="noStrike">
+                <a:solidFill>
+                  <a:srgbClr val="000000"/>
+                </a:solidFill>
+                <a:effectLst/>
+                <a:uFillTx/>
+                <a:latin typeface="Arial"/>
+              </a:rPr>
+              <a:t>notes format</a:t>
             </a:r>
             <a:endParaRPr lang="en-US" sz="2000" b="0" u="none" strike="noStrike">
               <a:solidFill>
@@ -374,7 +385,7 @@
             <a:pPr indent="0" algn="r">
               <a:buNone/>
             </a:pPr>
-            <a:fld id="{94675FC7-592F-483A-8D29-B166C4351913}" type="slidenum">
+            <a:fld id="{475A8E8B-BEDB-4988-A6BF-7C4E9B885585}" type="slidenum">
               <a:rPr lang="en-US" sz="1400" b="0" u="none" strike="noStrike">
                 <a:solidFill>
                   <a:srgbClr val="000000"/>
@@ -421,7 +432,7 @@
       </p:grpSpPr>
       <p:sp>
         <p:nvSpPr>
-          <p:cNvPr id="279" name="PlaceHolder 1"/>
+          <p:cNvPr id="278" name="PlaceHolder 1"/>
           <p:cNvSpPr>
             <a:spLocks noGrp="1"/>
           </p:cNvSpPr>
@@ -444,7 +455,7 @@
       </p:sp>
       <p:sp>
         <p:nvSpPr>
-          <p:cNvPr id="280" name="PlaceHolder 2"/>
+          <p:cNvPr id="279" name="PlaceHolder 2"/>
           <p:cNvSpPr>
             <a:spLocks noGrp="1"/>
           </p:cNvSpPr>
@@ -500,7 +511,7 @@
       </p:sp>
       <p:sp>
         <p:nvSpPr>
-          <p:cNvPr id="281" name="PlaceHolder 3"/>
+          <p:cNvPr id="280" name="PlaceHolder 3"/>
           <p:cNvSpPr>
             <a:spLocks noGrp="1"/>
           </p:cNvSpPr>
@@ -549,7 +560,7 @@
               </a:lnSpc>
               <a:buNone/>
             </a:pPr>
-            <a:fld id="{49CF8351-D572-4F6A-B9A4-774F366323D7}" type="slidenum">
+            <a:fld id="{F38677EB-BCFE-4A7F-B0B5-97CA1BA1A9A7}" type="slidenum">
               <a:rPr lang="en-US" sz="1200" b="0" u="none" strike="noStrike">
                 <a:solidFill>
                   <a:schemeClr val="dk1"/>
@@ -559,7 +570,7 @@
                 <a:latin typeface="+mn-lt"/>
                 <a:ea typeface="+mn-ea"/>
               </a:rPr>
-              <a:t>11</a:t>
+              <a:t>&lt;number&gt;</a:t>
             </a:fld>
             <a:endParaRPr lang="en-US" sz="1200" b="0" u="none" strike="noStrike">
               <a:solidFill>
@@ -596,7 +607,7 @@
       </p:grpSpPr>
       <p:sp>
         <p:nvSpPr>
-          <p:cNvPr id="306" name="PlaceHolder 1"/>
+          <p:cNvPr id="305" name="PlaceHolder 1"/>
           <p:cNvSpPr>
             <a:spLocks noGrp="1"/>
           </p:cNvSpPr>
@@ -619,7 +630,7 @@
       </p:sp>
       <p:sp>
         <p:nvSpPr>
-          <p:cNvPr id="307" name="PlaceHolder 2"/>
+          <p:cNvPr id="306" name="PlaceHolder 2"/>
           <p:cNvSpPr>
             <a:spLocks noGrp="1"/>
           </p:cNvSpPr>
@@ -675,7 +686,7 @@
       </p:sp>
       <p:sp>
         <p:nvSpPr>
-          <p:cNvPr id="308" name="PlaceHolder 3"/>
+          <p:cNvPr id="307" name="PlaceHolder 3"/>
           <p:cNvSpPr>
             <a:spLocks noGrp="1"/>
           </p:cNvSpPr>
@@ -724,7 +735,7 @@
               </a:lnSpc>
               <a:buNone/>
             </a:pPr>
-            <a:fld id="{129C685F-40F9-418D-A7FB-12E72BE7B5F3}" type="slidenum">
+            <a:fld id="{FB053A7E-0DE3-4E7A-957E-257F9CD0E0C3}" type="slidenum">
               <a:rPr lang="en-US" sz="1200" b="0" u="none" strike="noStrike">
                 <a:solidFill>
                   <a:schemeClr val="dk1"/>
@@ -771,7 +782,7 @@
       </p:grpSpPr>
       <p:sp>
         <p:nvSpPr>
-          <p:cNvPr id="309" name="PlaceHolder 1"/>
+          <p:cNvPr id="308" name="PlaceHolder 1"/>
           <p:cNvSpPr>
             <a:spLocks noGrp="1"/>
           </p:cNvSpPr>
@@ -794,7 +805,7 @@
       </p:sp>
       <p:sp>
         <p:nvSpPr>
-          <p:cNvPr id="310" name="PlaceHolder 2"/>
+          <p:cNvPr id="309" name="PlaceHolder 2"/>
           <p:cNvSpPr>
             <a:spLocks noGrp="1"/>
           </p:cNvSpPr>
@@ -850,7 +861,7 @@
       </p:sp>
       <p:sp>
         <p:nvSpPr>
-          <p:cNvPr id="311" name="PlaceHolder 3"/>
+          <p:cNvPr id="310" name="PlaceHolder 3"/>
           <p:cNvSpPr>
             <a:spLocks noGrp="1"/>
           </p:cNvSpPr>
@@ -899,7 +910,7 @@
               </a:lnSpc>
               <a:buNone/>
             </a:pPr>
-            <a:fld id="{35409D37-BB9D-4444-A152-471137721B69}" type="slidenum">
+            <a:fld id="{CCB95768-FCFD-46B4-B87F-9DFE09BFC12F}" type="slidenum">
               <a:rPr lang="en-US" sz="1200" b="0" u="none" strike="noStrike">
                 <a:solidFill>
                   <a:schemeClr val="dk1"/>
@@ -946,7 +957,7 @@
       </p:grpSpPr>
       <p:sp>
         <p:nvSpPr>
-          <p:cNvPr id="282" name="PlaceHolder 1"/>
+          <p:cNvPr id="281" name="PlaceHolder 1"/>
           <p:cNvSpPr>
             <a:spLocks noGrp="1"/>
           </p:cNvSpPr>
@@ -969,7 +980,7 @@
       </p:sp>
       <p:sp>
         <p:nvSpPr>
-          <p:cNvPr id="283" name="PlaceHolder 2"/>
+          <p:cNvPr id="282" name="PlaceHolder 2"/>
           <p:cNvSpPr>
             <a:spLocks noGrp="1"/>
           </p:cNvSpPr>
@@ -1025,7 +1036,7 @@
       </p:sp>
       <p:sp>
         <p:nvSpPr>
-          <p:cNvPr id="284" name="PlaceHolder 3"/>
+          <p:cNvPr id="283" name="PlaceHolder 3"/>
           <p:cNvSpPr>
             <a:spLocks noGrp="1"/>
           </p:cNvSpPr>
@@ -1074,7 +1085,7 @@
               </a:lnSpc>
               <a:buNone/>
             </a:pPr>
-            <a:fld id="{76B45AF0-6465-4EBE-B3B1-87A6836A8548}" type="slidenum">
+            <a:fld id="{77F73A12-404C-40EF-9BD2-7D41A6E48A67}" type="slidenum">
               <a:rPr lang="en-US" sz="1200" b="0" u="none" strike="noStrike">
                 <a:solidFill>
                   <a:schemeClr val="dk1"/>
@@ -1084,7 +1095,7 @@
                 <a:latin typeface="+mn-lt"/>
                 <a:ea typeface="+mn-ea"/>
               </a:rPr>
-              <a:t>11</a:t>
+              <a:t>&lt;number&gt;</a:t>
             </a:fld>
             <a:endParaRPr lang="en-US" sz="1200" b="0" u="none" strike="noStrike">
               <a:solidFill>
@@ -1121,7 +1132,7 @@
       </p:grpSpPr>
       <p:sp>
         <p:nvSpPr>
-          <p:cNvPr id="285" name="PlaceHolder 1"/>
+          <p:cNvPr id="284" name="PlaceHolder 1"/>
           <p:cNvSpPr>
             <a:spLocks noGrp="1"/>
           </p:cNvSpPr>
@@ -1144,7 +1155,7 @@
       </p:sp>
       <p:sp>
         <p:nvSpPr>
-          <p:cNvPr id="286" name="PlaceHolder 2"/>
+          <p:cNvPr id="285" name="PlaceHolder 2"/>
           <p:cNvSpPr>
             <a:spLocks noGrp="1"/>
           </p:cNvSpPr>
@@ -1200,7 +1211,7 @@
       </p:sp>
       <p:sp>
         <p:nvSpPr>
-          <p:cNvPr id="287" name="PlaceHolder 3"/>
+          <p:cNvPr id="286" name="PlaceHolder 3"/>
           <p:cNvSpPr>
             <a:spLocks noGrp="1"/>
           </p:cNvSpPr>
@@ -1249,7 +1260,7 @@
               </a:lnSpc>
               <a:buNone/>
             </a:pPr>
-            <a:fld id="{9E53CDA4-31B4-40E8-A4FF-58BC0A9DAEA9}" type="slidenum">
+            <a:fld id="{E994C129-A87D-4EFA-90B6-0E4D6CC8C011}" type="slidenum">
               <a:rPr lang="en-US" sz="1200" b="0" u="none" strike="noStrike">
                 <a:solidFill>
                   <a:schemeClr val="dk1"/>
@@ -1259,7 +1270,7 @@
                 <a:latin typeface="+mn-lt"/>
                 <a:ea typeface="+mn-ea"/>
               </a:rPr>
-              <a:t>11</a:t>
+              <a:t>&lt;number&gt;</a:t>
             </a:fld>
             <a:endParaRPr lang="en-US" sz="1200" b="0" u="none" strike="noStrike">
               <a:solidFill>
@@ -1296,7 +1307,7 @@
       </p:grpSpPr>
       <p:sp>
         <p:nvSpPr>
-          <p:cNvPr id="288" name="PlaceHolder 1"/>
+          <p:cNvPr id="287" name="PlaceHolder 1"/>
           <p:cNvSpPr>
             <a:spLocks noGrp="1"/>
           </p:cNvSpPr>
@@ -1319,7 +1330,7 @@
       </p:sp>
       <p:sp>
         <p:nvSpPr>
-          <p:cNvPr id="289" name="PlaceHolder 2"/>
+          <p:cNvPr id="288" name="PlaceHolder 2"/>
           <p:cNvSpPr>
             <a:spLocks noGrp="1"/>
           </p:cNvSpPr>
@@ -1360,7 +1371,7 @@
                 <a:uFillTx/>
                 <a:latin typeface="Arial"/>
               </a:rPr>
-              <a:t>So: three integrated activities under one coordinating body. Forest restoration. Distributed renewable energy and EV charging. A small, community-owned data center. Local solar powers the data center and the cars. The data center anchors the closed school back into village life. They share a single 25-year ledger of methods, finances, and outcomes — published openly.</a:t>
+              <a:t>So: three integrated activities under one coordinating body. Forest restoration. Distributed renewable energy and EV charging. A small, community-owned data center. The sugi we remove to make way for the native forest becomes the biomass that powers the data center and the cars — the conversion fuels the conversion. The data center anchors the closed school back into village life. They share a single 25-year ledger of methods, finances, and outcomes — published openly.</a:t>
             </a:r>
             <a:endParaRPr lang="en-US" sz="2000" b="0" u="none" strike="noStrike">
               <a:solidFill>
@@ -1375,7 +1386,7 @@
       </p:sp>
       <p:sp>
         <p:nvSpPr>
-          <p:cNvPr id="290" name="PlaceHolder 3"/>
+          <p:cNvPr id="289" name="PlaceHolder 3"/>
           <p:cNvSpPr>
             <a:spLocks noGrp="1"/>
           </p:cNvSpPr>
@@ -1424,7 +1435,7 @@
               </a:lnSpc>
               <a:buNone/>
             </a:pPr>
-            <a:fld id="{7F223793-A348-442A-B64A-C0CD87BFEA28}" type="slidenum">
+            <a:fld id="{EC8B6D06-920D-4810-89E7-5F8376D0A4A6}" type="slidenum">
               <a:rPr lang="en-US" sz="1200" b="0" u="none" strike="noStrike">
                 <a:solidFill>
                   <a:schemeClr val="dk1"/>
@@ -1434,7 +1445,7 @@
                 <a:latin typeface="+mn-lt"/>
                 <a:ea typeface="+mn-ea"/>
               </a:rPr>
-              <a:t>11</a:t>
+              <a:t>&lt;number&gt;</a:t>
             </a:fld>
             <a:endParaRPr lang="en-US" sz="1200" b="0" u="none" strike="noStrike">
               <a:solidFill>
@@ -1471,7 +1482,7 @@
       </p:grpSpPr>
       <p:sp>
         <p:nvSpPr>
-          <p:cNvPr id="291" name="PlaceHolder 1"/>
+          <p:cNvPr id="290" name="PlaceHolder 1"/>
           <p:cNvSpPr>
             <a:spLocks noGrp="1"/>
           </p:cNvSpPr>
@@ -1494,7 +1505,7 @@
       </p:sp>
       <p:sp>
         <p:nvSpPr>
-          <p:cNvPr id="292" name="PlaceHolder 2"/>
+          <p:cNvPr id="291" name="PlaceHolder 2"/>
           <p:cNvSpPr>
             <a:spLocks noGrp="1"/>
           </p:cNvSpPr>
@@ -1535,7 +1546,7 @@
                 <a:uFillTx/>
                 <a:latin typeface="Arial"/>
               </a:rPr>
-              <a:t>On forests: phased replacement of aged sugi cedar with native broadleaf — oak, chestnut, konara. The 25-year arc is the ecological clock, not the funding cycle. The community benefit is concrete: less pollen, fewer landslides, a forest that looks and behaves like a forest again. And when the forest produces acorns once more, the bears, boar, and deer find their winter food in the forest instead of in the village vegetable patch. It's the cheapest wildlife-management policy nobody's tried at scale.</a:t>
+              <a:t>On forests: phased replacement of aged sugi cedar with native broadleaf — oak, chestnut, konara. The 25-year arc is the ecological clock, not the funding cycle. The community benefit is concrete: less pollen, fewer landslides, a forest that looks and behaves like a forest again. Crucially, the sugi we remove doesn't go to waste — it becomes biomass fuel for the village's energy system. And when the broadleaf forest produces acorns, the bears, boar, and deer find their winter food in the forest instead of in the village vegetable patch.</a:t>
             </a:r>
             <a:endParaRPr lang="en-US" sz="2000" b="0" u="none" strike="noStrike">
               <a:solidFill>
@@ -1550,7 +1561,7 @@
       </p:sp>
       <p:sp>
         <p:nvSpPr>
-          <p:cNvPr id="293" name="PlaceHolder 3"/>
+          <p:cNvPr id="292" name="PlaceHolder 3"/>
           <p:cNvSpPr>
             <a:spLocks noGrp="1"/>
           </p:cNvSpPr>
@@ -1599,7 +1610,7 @@
               </a:lnSpc>
               <a:buNone/>
             </a:pPr>
-            <a:fld id="{44DB504C-FB8E-4305-B182-60311280A769}" type="slidenum">
+            <a:fld id="{0CCC8488-C664-4AA8-9D28-CAB3C2E16580}" type="slidenum">
               <a:rPr lang="en-US" sz="1200" b="0" u="none" strike="noStrike">
                 <a:solidFill>
                   <a:schemeClr val="dk1"/>
@@ -1609,7 +1620,7 @@
                 <a:latin typeface="+mn-lt"/>
                 <a:ea typeface="+mn-ea"/>
               </a:rPr>
-              <a:t>11</a:t>
+              <a:t>&lt;number&gt;</a:t>
             </a:fld>
             <a:endParaRPr lang="en-US" sz="1200" b="0" u="none" strike="noStrike">
               <a:solidFill>
@@ -1646,7 +1657,7 @@
       </p:grpSpPr>
       <p:sp>
         <p:nvSpPr>
-          <p:cNvPr id="294" name="PlaceHolder 1"/>
+          <p:cNvPr id="293" name="PlaceHolder 1"/>
           <p:cNvSpPr>
             <a:spLocks noGrp="1"/>
           </p:cNvSpPr>
@@ -1669,7 +1680,7 @@
       </p:sp>
       <p:sp>
         <p:nvSpPr>
-          <p:cNvPr id="295" name="PlaceHolder 2"/>
+          <p:cNvPr id="294" name="PlaceHolder 2"/>
           <p:cNvSpPr>
             <a:spLocks noGrp="1"/>
           </p:cNvSpPr>
@@ -1710,7 +1721,7 @@
                 <a:uFillTx/>
                 <a:latin typeface="Arial"/>
               </a:rPr>
-              <a:t>One unified electrical system. Privately-owned solar on a shared village bus. EV chargers tied to local generation instead of waiting on grid extension. And — this is the part the village cares about most — the data center's on-site generation keeps the school, the clinic, and emergency facilities running through blackouts. Aging distribution lines make outages a real and growing risk. Resilience is built in, not bolted on.</a:t>
+              <a:t>One unified electrical system. The sugi removed during the forest conversion is the primary fuel — a biomass plant on a shared village bus. Local solar tops it up. A community battery rides through the dark hours. The grid is backup only. EV chargers tie to local generation instead of waiting on grid extension. And — this is the part the village cares about most — on-site generation keeps the school, the clinic, and emergency facilities running through blackouts. Aging distribution lines make outages a real and growing risk. Resilience is built in, not bolted on.</a:t>
             </a:r>
             <a:endParaRPr lang="en-US" sz="2000" b="0" u="none" strike="noStrike">
               <a:solidFill>
@@ -1725,7 +1736,7 @@
       </p:sp>
       <p:sp>
         <p:nvSpPr>
-          <p:cNvPr id="296" name="PlaceHolder 3"/>
+          <p:cNvPr id="295" name="PlaceHolder 3"/>
           <p:cNvSpPr>
             <a:spLocks noGrp="1"/>
           </p:cNvSpPr>
@@ -1774,7 +1785,7 @@
               </a:lnSpc>
               <a:buNone/>
             </a:pPr>
-            <a:fld id="{9C2178B1-CFFD-4FBA-80CB-C1BF09E295B9}" type="slidenum">
+            <a:fld id="{B7762E9B-153D-47E4-8D12-31BE0A3CFAC0}" type="slidenum">
               <a:rPr lang="en-US" sz="1200" b="0" u="none" strike="noStrike">
                 <a:solidFill>
                   <a:schemeClr val="dk1"/>
@@ -1784,7 +1795,7 @@
                 <a:latin typeface="+mn-lt"/>
                 <a:ea typeface="+mn-ea"/>
               </a:rPr>
-              <a:t>11</a:t>
+              <a:t>&lt;number&gt;</a:t>
             </a:fld>
             <a:endParaRPr lang="en-US" sz="1200" b="0" u="none" strike="noStrike">
               <a:solidFill>
@@ -1821,7 +1832,7 @@
       </p:grpSpPr>
       <p:sp>
         <p:nvSpPr>
-          <p:cNvPr id="297" name="PlaceHolder 1"/>
+          <p:cNvPr id="296" name="PlaceHolder 1"/>
           <p:cNvSpPr>
             <a:spLocks noGrp="1"/>
           </p:cNvSpPr>
@@ -1844,7 +1855,7 @@
       </p:sp>
       <p:sp>
         <p:nvSpPr>
-          <p:cNvPr id="298" name="PlaceHolder 2"/>
+          <p:cNvPr id="297" name="PlaceHolder 2"/>
           <p:cNvSpPr>
             <a:spLocks noGrp="1"/>
           </p:cNvSpPr>
@@ -1900,7 +1911,7 @@
       </p:sp>
       <p:sp>
         <p:nvSpPr>
-          <p:cNvPr id="299" name="PlaceHolder 3"/>
+          <p:cNvPr id="298" name="PlaceHolder 3"/>
           <p:cNvSpPr>
             <a:spLocks noGrp="1"/>
           </p:cNvSpPr>
@@ -1949,7 +1960,7 @@
               </a:lnSpc>
               <a:buNone/>
             </a:pPr>
-            <a:fld id="{3D90C340-440C-46AC-953B-96659E16E19C}" type="slidenum">
+            <a:fld id="{D07ECBAD-4A22-4D51-80F5-763C48CDAEE0}" type="slidenum">
               <a:rPr lang="en-US" sz="1200" b="0" u="none" strike="noStrike">
                 <a:solidFill>
                   <a:schemeClr val="dk1"/>
@@ -1996,7 +2007,7 @@
       </p:grpSpPr>
       <p:sp>
         <p:nvSpPr>
-          <p:cNvPr id="300" name="PlaceHolder 1"/>
+          <p:cNvPr id="299" name="PlaceHolder 1"/>
           <p:cNvSpPr>
             <a:spLocks noGrp="1"/>
           </p:cNvSpPr>
@@ -2019,7 +2030,7 @@
       </p:sp>
       <p:sp>
         <p:nvSpPr>
-          <p:cNvPr id="301" name="PlaceHolder 2"/>
+          <p:cNvPr id="300" name="PlaceHolder 2"/>
           <p:cNvSpPr>
             <a:spLocks noGrp="1"/>
           </p:cNvSpPr>
@@ -2075,7 +2086,7 @@
       </p:sp>
       <p:sp>
         <p:nvSpPr>
-          <p:cNvPr id="302" name="PlaceHolder 3"/>
+          <p:cNvPr id="301" name="PlaceHolder 3"/>
           <p:cNvSpPr>
             <a:spLocks noGrp="1"/>
           </p:cNvSpPr>
@@ -2124,7 +2135,7 @@
               </a:lnSpc>
               <a:buNone/>
             </a:pPr>
-            <a:fld id="{A76E7226-2259-4F64-86C2-AC2ACF3E8284}" type="slidenum">
+            <a:fld id="{30438D0D-1EA0-46F6-ABF7-8980F901FD31}" type="slidenum">
               <a:rPr lang="en-US" sz="1200" b="0" u="none" strike="noStrike">
                 <a:solidFill>
                   <a:schemeClr val="dk1"/>
@@ -2171,7 +2182,7 @@
       </p:grpSpPr>
       <p:sp>
         <p:nvSpPr>
-          <p:cNvPr id="303" name="PlaceHolder 1"/>
+          <p:cNvPr id="302" name="PlaceHolder 1"/>
           <p:cNvSpPr>
             <a:spLocks noGrp="1"/>
           </p:cNvSpPr>
@@ -2194,7 +2205,7 @@
       </p:sp>
       <p:sp>
         <p:nvSpPr>
-          <p:cNvPr id="304" name="PlaceHolder 2"/>
+          <p:cNvPr id="303" name="PlaceHolder 2"/>
           <p:cNvSpPr>
             <a:spLocks noGrp="1"/>
           </p:cNvSpPr>
@@ -2250,7 +2261,7 @@
       </p:sp>
       <p:sp>
         <p:nvSpPr>
-          <p:cNvPr id="305" name="PlaceHolder 3"/>
+          <p:cNvPr id="304" name="PlaceHolder 3"/>
           <p:cNvSpPr>
             <a:spLocks noGrp="1"/>
           </p:cNvSpPr>
@@ -2299,7 +2310,7 @@
               </a:lnSpc>
               <a:buNone/>
             </a:pPr>
-            <a:fld id="{5C1FFA1B-8C7E-4C2A-87F7-61CA83011C1C}" type="slidenum">
+            <a:fld id="{A104C59D-D30D-4F8A-968E-3F7CF29B7FCF}" type="slidenum">
               <a:rPr lang="en-US" sz="1200" b="0" u="none" strike="noStrike">
                 <a:solidFill>
                   <a:schemeClr val="dk1"/>
@@ -2911,7 +2922,7 @@
         </p:nvSpPr>
         <p:spPr>
           <a:xfrm>
-            <a:off x="1155600" y="834120"/>
+            <a:off x="1047600" y="762120"/>
             <a:ext cx="609120" cy="571320"/>
           </a:xfrm>
           <a:prstGeom prst="rect">
@@ -3085,7 +3096,19 @@
                 <a:latin typeface="Courier New"/>
                 <a:ea typeface="Courier New"/>
               </a:rPr>
-              <a:t>FOUNDATION · MAY 2026</a:t>
+              <a:t>FOUNDATION · MAY </a:t>
+            </a:r>
+            <a:r>
+              <a:rPr lang="en-US" sz="1800" b="0" u="none" spc="145" strike="noStrike">
+                <a:solidFill>
+                  <a:srgbClr val="4C554F"/>
+                </a:solidFill>
+                <a:effectLst/>
+                <a:uFillTx/>
+                <a:latin typeface="Courier New"/>
+                <a:ea typeface="Courier New"/>
+              </a:rPr>
+              <a:t>2026</a:t>
             </a:r>
             <a:endParaRPr lang="en-US" sz="1800" b="0" u="none" strike="noStrike">
               <a:solidFill>
@@ -3146,10 +3169,10 @@
                 <a:latin typeface="Courier New"/>
                 <a:ea typeface="Courier New"/>
               </a:rPr>
-              <a:t>A 25-</a:t>
-            </a:r>
-            <a:r>
-              <a:rPr lang="en-US" sz="1800" b="0" u="none" spc="215" strike="noStrike">
+              <a:t>A 25-YEAR INITIATIVE · </a:t>
+            </a:r>
+            <a:r>
+              <a:rPr lang="zh-CN" sz="1800" b="0" u="none" spc="215" strike="noStrike">
                 <a:solidFill>
                   <a:srgbClr val="4C554F"/>
                 </a:solidFill>
@@ -3158,55 +3181,7 @@
                 <a:latin typeface="Courier New"/>
                 <a:ea typeface="Courier New"/>
               </a:rPr>
-              <a:t>YEAR </a:t>
-            </a:r>
-            <a:r>
-              <a:rPr lang="en-US" sz="1800" b="0" u="none" spc="215" strike="noStrike">
-                <a:solidFill>
-                  <a:srgbClr val="4C554F"/>
-                </a:solidFill>
-                <a:effectLst/>
-                <a:uFillTx/>
-                <a:latin typeface="Courier New"/>
-                <a:ea typeface="Courier New"/>
-              </a:rPr>
-              <a:t>INITIA</a:t>
-            </a:r>
-            <a:r>
-              <a:rPr lang="en-US" sz="1800" b="0" u="none" spc="215" strike="noStrike">
-                <a:solidFill>
-                  <a:srgbClr val="4C554F"/>
-                </a:solidFill>
-                <a:effectLst/>
-                <a:uFillTx/>
-                <a:latin typeface="Courier New"/>
-                <a:ea typeface="Courier New"/>
-              </a:rPr>
-              <a:t>TIVE · </a:t>
-            </a:r>
-            <a:r>
-              <a:rPr lang="zh-CN" sz="1800" b="0" u="none" spc="215" strike="noStrike">
-                <a:solidFill>
-                  <a:srgbClr val="4C554F"/>
-                </a:solidFill>
-                <a:effectLst/>
-                <a:uFillTx/>
-                <a:latin typeface="Courier New"/>
-                <a:ea typeface="Courier New"/>
-              </a:rPr>
-              <a:t>二十五年</a:t>
-            </a:r>
-            <a:r>
-              <a:rPr lang="zh-CN" sz="1800" b="0" u="none" spc="215" strike="noStrike">
-                <a:solidFill>
-                  <a:srgbClr val="4C554F"/>
-                </a:solidFill>
-                <a:effectLst/>
-                <a:uFillTx/>
-                <a:latin typeface="Courier New"/>
-                <a:ea typeface="Courier New"/>
-              </a:rPr>
-              <a:t>計画</a:t>
+              <a:t>二十五年計画</a:t>
             </a:r>
             <a:endParaRPr lang="en-US" sz="1800" b="0" u="none" strike="noStrike">
               <a:solidFill>
@@ -3267,19 +3242,79 @@
                 <a:latin typeface="Georgia"/>
                 <a:ea typeface="Georgia"/>
               </a:rPr>
-              <a:t>A modest plan for a small village in the </a:t>
-            </a:r>
-            <a:r>
-              <a:rPr lang="en-US" sz="9600" b="0" i="1" u="none" spc="-96" strike="noStrike">
-                <a:solidFill>
-                  <a:srgbClr val="C4663A"/>
+              <a:t>A modest </a:t>
+            </a:r>
+            <a:r>
+              <a:rPr lang="en-US" sz="9600" b="0" u="none" spc="-96" strike="noStrike">
+                <a:solidFill>
+                  <a:srgbClr val="1F2A24"/>
                 </a:solidFill>
                 <a:effectLst/>
                 <a:uFillTx/>
                 <a:latin typeface="Georgia"/>
                 <a:ea typeface="Georgia"/>
               </a:rPr>
-              <a:t>mountains.</a:t>
+              <a:t>plan for a </a:t>
+            </a:r>
+            <a:r>
+              <a:rPr lang="en-US" sz="9600" b="0" u="none" spc="-96" strike="noStrike">
+                <a:solidFill>
+                  <a:srgbClr val="1F2A24"/>
+                </a:solidFill>
+                <a:effectLst/>
+                <a:uFillTx/>
+                <a:latin typeface="Georgia"/>
+                <a:ea typeface="Georgia"/>
+              </a:rPr>
+              <a:t>small </a:t>
+            </a:r>
+            <a:r>
+              <a:rPr lang="en-US" sz="9600" b="0" u="none" spc="-96" strike="noStrike">
+                <a:solidFill>
+                  <a:srgbClr val="1F2A24"/>
+                </a:solidFill>
+                <a:effectLst/>
+                <a:uFillTx/>
+                <a:latin typeface="Georgia"/>
+                <a:ea typeface="Georgia"/>
+              </a:rPr>
+              <a:t>village in </a:t>
+            </a:r>
+            <a:r>
+              <a:rPr lang="en-US" sz="9600" b="0" u="none" spc="-96" strike="noStrike">
+                <a:solidFill>
+                  <a:srgbClr val="1F2A24"/>
+                </a:solidFill>
+                <a:effectLst/>
+                <a:uFillTx/>
+                <a:latin typeface="Georgia"/>
+                <a:ea typeface="Georgia"/>
+              </a:rPr>
+              <a:t>the </a:t>
+            </a:r>
+            <a:r>
+              <a:rPr lang="en-US" sz="9600" b="0" i="1" u="none" spc="-96" strike="noStrike">
+                <a:solidFill>
+                  <a:srgbClr val="C4663A"/>
+                </a:solidFill>
+                <a:effectLst/>
+                <a:uFillTx/>
+                <a:latin typeface="Georgia"/>
+                <a:ea typeface="Georgia"/>
+              </a:rPr>
+              <a:t>mountain</a:t>
+            </a:r>
+            <a:r>
+              <a:rPr lang="en-US" sz="9600" b="0" i="1" u="none" spc="-96" strike="noStrike">
+                <a:solidFill>
+                  <a:srgbClr val="C4663A"/>
+                </a:solidFill>
+                <a:effectLst/>
+                <a:uFillTx/>
+                <a:latin typeface="Georgia"/>
+                <a:ea typeface="Georgia"/>
+              </a:rPr>
+              <a:t>s.</a:t>
             </a:r>
             <a:endParaRPr lang="en-US" sz="9600" b="0" u="none" strike="noStrike">
               <a:solidFill>
@@ -3340,7 +3375,19 @@
                 <a:latin typeface="Noto Serif JP"/>
                 <a:ea typeface="Noto Serif JP"/>
               </a:rPr>
-              <a:t>奈良県御杖村 森林・分散型エネルギー・地域所有のデータセンター</a:t>
+              <a:t>奈良県御杖村 森林・分散型エネルギ</a:t>
+            </a:r>
+            <a:r>
+              <a:rPr lang="zh-CN" sz="2250" b="0" u="none" strike="noStrike">
+                <a:solidFill>
+                  <a:srgbClr val="4C554F"/>
+                </a:solidFill>
+                <a:effectLst/>
+                <a:uFillTx/>
+                <a:latin typeface="Noto Serif JP"/>
+                <a:ea typeface="Noto Serif JP"/>
+              </a:rPr>
+              <a:t>ー・地域所有のデータセンター</a:t>
             </a:r>
             <a:endParaRPr lang="en-US" sz="2250" b="0" u="none" strike="noStrike">
               <a:solidFill>
@@ -3550,7 +3597,7 @@
       </p:grpSpPr>
       <p:sp>
         <p:nvSpPr>
-          <p:cNvPr id="184" name="Shape 0"/>
+          <p:cNvPr id="183" name="Shape 0"/>
           <p:cNvSpPr/>
           <p:nvPr/>
         </p:nvSpPr>
@@ -3593,13 +3640,13 @@
       </p:sp>
       <p:sp>
         <p:nvSpPr>
-          <p:cNvPr id="185" name="Text 1"/>
-          <p:cNvSpPr/>
-          <p:nvPr/>
-        </p:nvSpPr>
-        <p:spPr>
-          <a:xfrm>
-            <a:off x="1119600" y="798120"/>
+          <p:cNvPr id="184" name="Text 1"/>
+          <p:cNvSpPr/>
+          <p:nvPr/>
+        </p:nvSpPr>
+        <p:spPr>
+          <a:xfrm>
+            <a:off x="1047600" y="762120"/>
             <a:ext cx="533160" cy="495000"/>
           </a:xfrm>
           <a:prstGeom prst="rect">
@@ -3654,7 +3701,7 @@
       </p:sp>
       <p:sp>
         <p:nvSpPr>
-          <p:cNvPr id="186" name="Text 2"/>
+          <p:cNvPr id="185" name="Text 2"/>
           <p:cNvSpPr/>
           <p:nvPr/>
         </p:nvSpPr>
@@ -3715,7 +3762,7 @@
       </p:sp>
       <p:sp>
         <p:nvSpPr>
-          <p:cNvPr id="187" name="Text 3"/>
+          <p:cNvPr id="186" name="Text 3"/>
           <p:cNvSpPr/>
           <p:nvPr/>
         </p:nvSpPr>
@@ -3776,7 +3823,7 @@
       </p:sp>
       <p:sp>
         <p:nvSpPr>
-          <p:cNvPr id="188" name="Text 4"/>
+          <p:cNvPr id="187" name="Text 4"/>
           <p:cNvSpPr/>
           <p:nvPr/>
         </p:nvSpPr>
@@ -3861,7 +3908,7 @@
       </p:sp>
       <p:sp>
         <p:nvSpPr>
-          <p:cNvPr id="189" name="Text 5"/>
+          <p:cNvPr id="188" name="Text 5"/>
           <p:cNvSpPr/>
           <p:nvPr/>
         </p:nvSpPr>
@@ -3922,7 +3969,7 @@
       </p:sp>
       <p:sp>
         <p:nvSpPr>
-          <p:cNvPr id="190" name="Shape 6"/>
+          <p:cNvPr id="189" name="Shape 6"/>
           <p:cNvSpPr/>
           <p:nvPr/>
         </p:nvSpPr>
@@ -3968,7 +4015,7 @@
       </p:sp>
       <p:sp>
         <p:nvSpPr>
-          <p:cNvPr id="191" name="Text 7"/>
+          <p:cNvPr id="190" name="Text 7"/>
           <p:cNvSpPr/>
           <p:nvPr/>
         </p:nvSpPr>
@@ -4031,7 +4078,7 @@
       </p:sp>
       <p:sp>
         <p:nvSpPr>
-          <p:cNvPr id="192" name="Text 8"/>
+          <p:cNvPr id="191" name="Text 8"/>
           <p:cNvSpPr/>
           <p:nvPr/>
         </p:nvSpPr>
@@ -4092,7 +4139,7 @@
       </p:sp>
       <p:sp>
         <p:nvSpPr>
-          <p:cNvPr id="193" name="Text 9"/>
+          <p:cNvPr id="192" name="Text 9"/>
           <p:cNvSpPr/>
           <p:nvPr/>
         </p:nvSpPr>
@@ -4155,7 +4202,7 @@
       </p:sp>
       <p:sp>
         <p:nvSpPr>
-          <p:cNvPr id="194" name="Shape 10"/>
+          <p:cNvPr id="193" name="Shape 10"/>
           <p:cNvSpPr/>
           <p:nvPr/>
         </p:nvSpPr>
@@ -4201,7 +4248,7 @@
       </p:sp>
       <p:sp>
         <p:nvSpPr>
-          <p:cNvPr id="195" name="Text 11"/>
+          <p:cNvPr id="194" name="Text 11"/>
           <p:cNvSpPr/>
           <p:nvPr/>
         </p:nvSpPr>
@@ -4262,7 +4309,7 @@
       </p:sp>
       <p:sp>
         <p:nvSpPr>
-          <p:cNvPr id="196" name="Text 12"/>
+          <p:cNvPr id="195" name="Text 12"/>
           <p:cNvSpPr/>
           <p:nvPr/>
         </p:nvSpPr>
@@ -4323,7 +4370,7 @@
       </p:sp>
       <p:sp>
         <p:nvSpPr>
-          <p:cNvPr id="197" name="Text 13"/>
+          <p:cNvPr id="196" name="Text 13"/>
           <p:cNvSpPr/>
           <p:nvPr/>
         </p:nvSpPr>
@@ -4384,7 +4431,7 @@
       </p:sp>
       <p:sp>
         <p:nvSpPr>
-          <p:cNvPr id="198" name="Shape 14"/>
+          <p:cNvPr id="197" name="Shape 14"/>
           <p:cNvSpPr/>
           <p:nvPr/>
         </p:nvSpPr>
@@ -4430,7 +4477,7 @@
       </p:sp>
       <p:sp>
         <p:nvSpPr>
-          <p:cNvPr id="199" name="Text 15"/>
+          <p:cNvPr id="198" name="Text 15"/>
           <p:cNvSpPr/>
           <p:nvPr/>
         </p:nvSpPr>
@@ -4491,7 +4538,7 @@
       </p:sp>
       <p:sp>
         <p:nvSpPr>
-          <p:cNvPr id="200" name="Text 16"/>
+          <p:cNvPr id="199" name="Text 16"/>
           <p:cNvSpPr/>
           <p:nvPr/>
         </p:nvSpPr>
@@ -4552,7 +4599,7 @@
       </p:sp>
       <p:sp>
         <p:nvSpPr>
-          <p:cNvPr id="201" name="Text 17"/>
+          <p:cNvPr id="200" name="Text 17"/>
           <p:cNvSpPr/>
           <p:nvPr/>
         </p:nvSpPr>
@@ -4613,7 +4660,7 @@
       </p:sp>
       <p:sp>
         <p:nvSpPr>
-          <p:cNvPr id="202" name="Shape 18"/>
+          <p:cNvPr id="201" name="Shape 18"/>
           <p:cNvSpPr/>
           <p:nvPr/>
         </p:nvSpPr>
@@ -4659,7 +4706,7 @@
       </p:sp>
       <p:sp>
         <p:nvSpPr>
-          <p:cNvPr id="203" name="Text 19"/>
+          <p:cNvPr id="202" name="Text 19"/>
           <p:cNvSpPr/>
           <p:nvPr/>
         </p:nvSpPr>
@@ -4720,7 +4767,7 @@
       </p:sp>
       <p:sp>
         <p:nvSpPr>
-          <p:cNvPr id="204" name="Text 20"/>
+          <p:cNvPr id="203" name="Text 20"/>
           <p:cNvSpPr/>
           <p:nvPr/>
         </p:nvSpPr>
@@ -4781,7 +4828,7 @@
       </p:sp>
       <p:sp>
         <p:nvSpPr>
-          <p:cNvPr id="205" name="Text 21"/>
+          <p:cNvPr id="204" name="Text 21"/>
           <p:cNvSpPr/>
           <p:nvPr/>
         </p:nvSpPr>
@@ -4842,7 +4889,7 @@
       </p:sp>
       <p:sp>
         <p:nvSpPr>
-          <p:cNvPr id="206" name="Shape 22"/>
+          <p:cNvPr id="205" name="Shape 22"/>
           <p:cNvSpPr/>
           <p:nvPr/>
         </p:nvSpPr>
@@ -4888,7 +4935,7 @@
       </p:sp>
       <p:sp>
         <p:nvSpPr>
-          <p:cNvPr id="207" name="Text 23"/>
+          <p:cNvPr id="206" name="Text 23"/>
           <p:cNvSpPr/>
           <p:nvPr/>
         </p:nvSpPr>
@@ -4949,7 +4996,7 @@
       </p:sp>
       <p:sp>
         <p:nvSpPr>
-          <p:cNvPr id="208" name="Text 24"/>
+          <p:cNvPr id="207" name="Text 24"/>
           <p:cNvSpPr/>
           <p:nvPr/>
         </p:nvSpPr>
@@ -5010,7 +5057,7 @@
       </p:sp>
       <p:sp>
         <p:nvSpPr>
-          <p:cNvPr id="209" name="Text 25"/>
+          <p:cNvPr id="208" name="Text 25"/>
           <p:cNvSpPr/>
           <p:nvPr/>
         </p:nvSpPr>
@@ -5071,7 +5118,7 @@
       </p:sp>
       <p:sp>
         <p:nvSpPr>
-          <p:cNvPr id="210" name="Text 26"/>
+          <p:cNvPr id="209" name="Text 26"/>
           <p:cNvSpPr/>
           <p:nvPr/>
         </p:nvSpPr>
@@ -5132,7 +5179,7 @@
       </p:sp>
       <p:sp>
         <p:nvSpPr>
-          <p:cNvPr id="211" name="Text 27"/>
+          <p:cNvPr id="210" name="Text 27"/>
           <p:cNvSpPr/>
           <p:nvPr/>
         </p:nvSpPr>
@@ -5193,7 +5240,7 @@
       </p:sp>
       <p:sp>
         <p:nvSpPr>
-          <p:cNvPr id="212" name="Text 28"/>
+          <p:cNvPr id="211" name="Text 28"/>
           <p:cNvSpPr/>
           <p:nvPr/>
         </p:nvSpPr>
@@ -5254,7 +5301,7 @@
       </p:sp>
       <p:sp>
         <p:nvSpPr>
-          <p:cNvPr id="213" name="Text 29"/>
+          <p:cNvPr id="212" name="Text 29"/>
           <p:cNvSpPr/>
           <p:nvPr/>
         </p:nvSpPr>
@@ -5300,8 +5347,57 @@
                 <a:latin typeface="Courier New"/>
                 <a:ea typeface="Courier New"/>
               </a:rPr>
-              <a:t>G4 · REVENUE </a:t>
-            </a:r>
+              <a:t>G4 · REVENUE ONLINE</a:t>
+            </a:r>
+            <a:endParaRPr lang="en-US" sz="1800" b="0" u="none" strike="noStrike">
+              <a:solidFill>
+                <a:srgbClr val="000000"/>
+              </a:solidFill>
+              <a:effectLst/>
+              <a:uFillTx/>
+              <a:latin typeface="Arial"/>
+            </a:endParaRPr>
+          </a:p>
+        </p:txBody>
+      </p:sp>
+      <p:sp>
+        <p:nvSpPr>
+          <p:cNvPr id="213" name="Text 30"/>
+          <p:cNvSpPr/>
+          <p:nvPr/>
+        </p:nvSpPr>
+        <p:spPr>
+          <a:xfrm>
+            <a:off x="1047600" y="6557040"/>
+            <a:ext cx="9453960" cy="304560"/>
+          </a:xfrm>
+          <a:prstGeom prst="rect">
+            <a:avLst/>
+          </a:prstGeom>
+          <a:noFill/>
+          <a:ln w="0">
+            <a:noFill/>
+          </a:ln>
+        </p:spPr>
+        <p:style>
+          <a:lnRef idx="0"/>
+          <a:fillRef idx="0"/>
+          <a:effectRef idx="0"/>
+          <a:fontRef idx="minor"/>
+        </p:style>
+        <p:txBody>
+          <a:bodyPr lIns="25560" tIns="25560" rIns="25560" bIns="25560" anchor="t">
+            <a:normAutofit lnSpcReduction="9999"/>
+          </a:bodyPr>
+          <a:p>
+            <a:pPr defTabSz="914400">
+              <a:lnSpc>
+                <a:spcPct val="100000"/>
+              </a:lnSpc>
+              <a:tabLst>
+                <a:tab pos="0" algn="l"/>
+              </a:tabLst>
+            </a:pPr>
             <a:r>
               <a:rPr lang="en-US" sz="1800" b="0" u="none" spc="215" strike="noStrike">
                 <a:solidFill>
@@ -5312,7 +5408,7 @@
                 <a:latin typeface="Courier New"/>
                 <a:ea typeface="Courier New"/>
               </a:rPr>
-              <a:t>ONLINE</a:t>
+              <a:t>FIVE-LAYER FUNDING STACK · YEAR-3 TARGET ≈ ¥134M</a:t>
             </a:r>
             <a:endParaRPr lang="en-US" sz="1800" b="0" u="none" strike="noStrike">
               <a:solidFill>
@@ -5327,92 +5423,7 @@
       </p:sp>
       <p:sp>
         <p:nvSpPr>
-          <p:cNvPr id="214" name="Text 30"/>
-          <p:cNvSpPr/>
-          <p:nvPr/>
-        </p:nvSpPr>
-        <p:spPr>
-          <a:xfrm>
-            <a:off x="1047600" y="6557040"/>
-            <a:ext cx="9453960" cy="304560"/>
-          </a:xfrm>
-          <a:prstGeom prst="rect">
-            <a:avLst/>
-          </a:prstGeom>
-          <a:noFill/>
-          <a:ln w="0">
-            <a:noFill/>
-          </a:ln>
-        </p:spPr>
-        <p:style>
-          <a:lnRef idx="0"/>
-          <a:fillRef idx="0"/>
-          <a:effectRef idx="0"/>
-          <a:fontRef idx="minor"/>
-        </p:style>
-        <p:txBody>
-          <a:bodyPr lIns="25560" tIns="25560" rIns="25560" bIns="25560" anchor="t">
-            <a:normAutofit lnSpcReduction="9999"/>
-          </a:bodyPr>
-          <a:p>
-            <a:pPr defTabSz="914400">
-              <a:lnSpc>
-                <a:spcPct val="100000"/>
-              </a:lnSpc>
-              <a:tabLst>
-                <a:tab pos="0" algn="l"/>
-              </a:tabLst>
-            </a:pPr>
-            <a:r>
-              <a:rPr lang="en-US" sz="1800" b="0" u="none" spc="215" strike="noStrike">
-                <a:solidFill>
-                  <a:srgbClr val="4C554F"/>
-                </a:solidFill>
-                <a:effectLst/>
-                <a:uFillTx/>
-                <a:latin typeface="Courier New"/>
-                <a:ea typeface="Courier New"/>
-              </a:rPr>
-              <a:t>FIVE-LAYER FUNDING </a:t>
-            </a:r>
-            <a:r>
-              <a:rPr lang="en-US" sz="1800" b="0" u="none" spc="215" strike="noStrike">
-                <a:solidFill>
-                  <a:srgbClr val="4C554F"/>
-                </a:solidFill>
-                <a:effectLst/>
-                <a:uFillTx/>
-                <a:latin typeface="Courier New"/>
-                <a:ea typeface="Courier New"/>
-              </a:rPr>
-              <a:t>STACK · YEAR-3 </a:t>
-            </a:r>
-            <a:r>
-              <a:rPr lang="en-US" sz="1800" b="0" u="none" spc="215" strike="noStrike">
-                <a:solidFill>
-                  <a:srgbClr val="4C554F"/>
-                </a:solidFill>
-                <a:effectLst/>
-                <a:uFillTx/>
-                <a:latin typeface="Courier New"/>
-                <a:ea typeface="Courier New"/>
-              </a:rPr>
-              <a:t>TARGET ≈ ¥134M</a:t>
-            </a:r>
-            <a:endParaRPr lang="en-US" sz="1800" b="0" u="none" strike="noStrike">
-              <a:solidFill>
-                <a:srgbClr val="000000"/>
-              </a:solidFill>
-              <a:effectLst/>
-              <a:uFillTx/>
-              <a:latin typeface="Arial"/>
-            </a:endParaRPr>
-          </a:p>
-        </p:txBody>
-      </p:sp>
-      <p:sp>
-        <p:nvSpPr>
-          <p:cNvPr id="215" name="Shape 31"/>
+          <p:cNvPr id="214" name="Shape 31"/>
           <p:cNvSpPr/>
           <p:nvPr/>
         </p:nvSpPr>
@@ -5455,7 +5466,7 @@
       </p:sp>
       <p:sp>
         <p:nvSpPr>
-          <p:cNvPr id="216" name="Text 32"/>
+          <p:cNvPr id="215" name="Text 32"/>
           <p:cNvSpPr/>
           <p:nvPr/>
         </p:nvSpPr>
@@ -5516,7 +5527,7 @@
       </p:sp>
       <p:sp>
         <p:nvSpPr>
-          <p:cNvPr id="217" name="Text 33"/>
+          <p:cNvPr id="216" name="Text 33"/>
           <p:cNvSpPr/>
           <p:nvPr/>
         </p:nvSpPr>
@@ -5577,7 +5588,7 @@
       </p:sp>
       <p:sp>
         <p:nvSpPr>
-          <p:cNvPr id="218" name="Text 34"/>
+          <p:cNvPr id="217" name="Text 34"/>
           <p:cNvSpPr/>
           <p:nvPr/>
         </p:nvSpPr>
@@ -5638,7 +5649,7 @@
       </p:sp>
       <p:sp>
         <p:nvSpPr>
-          <p:cNvPr id="219" name="Text 35"/>
+          <p:cNvPr id="218" name="Text 35"/>
           <p:cNvSpPr/>
           <p:nvPr/>
         </p:nvSpPr>
@@ -5699,7 +5710,7 @@
       </p:sp>
       <p:sp>
         <p:nvSpPr>
-          <p:cNvPr id="220" name="Shape 36"/>
+          <p:cNvPr id="219" name="Shape 36"/>
           <p:cNvSpPr/>
           <p:nvPr/>
         </p:nvSpPr>
@@ -5744,7 +5755,7 @@
       </p:sp>
       <p:sp>
         <p:nvSpPr>
-          <p:cNvPr id="221" name="Text 37"/>
+          <p:cNvPr id="220" name="Text 37"/>
           <p:cNvSpPr/>
           <p:nvPr/>
         </p:nvSpPr>
@@ -5805,7 +5816,7 @@
       </p:sp>
       <p:sp>
         <p:nvSpPr>
-          <p:cNvPr id="222" name="Text 38"/>
+          <p:cNvPr id="221" name="Text 38"/>
           <p:cNvSpPr/>
           <p:nvPr/>
         </p:nvSpPr>
@@ -5866,7 +5877,7 @@
       </p:sp>
       <p:sp>
         <p:nvSpPr>
-          <p:cNvPr id="223" name="Text 39"/>
+          <p:cNvPr id="222" name="Text 39"/>
           <p:cNvSpPr/>
           <p:nvPr/>
         </p:nvSpPr>
@@ -5927,7 +5938,7 @@
       </p:sp>
       <p:sp>
         <p:nvSpPr>
-          <p:cNvPr id="224" name="Text 40"/>
+          <p:cNvPr id="223" name="Text 40"/>
           <p:cNvSpPr/>
           <p:nvPr/>
         </p:nvSpPr>
@@ -5988,7 +5999,7 @@
       </p:sp>
       <p:sp>
         <p:nvSpPr>
-          <p:cNvPr id="225" name="Shape 41"/>
+          <p:cNvPr id="224" name="Shape 41"/>
           <p:cNvSpPr/>
           <p:nvPr/>
         </p:nvSpPr>
@@ -6033,7 +6044,7 @@
       </p:sp>
       <p:sp>
         <p:nvSpPr>
-          <p:cNvPr id="226" name="Text 42"/>
+          <p:cNvPr id="225" name="Text 42"/>
           <p:cNvSpPr/>
           <p:nvPr/>
         </p:nvSpPr>
@@ -6094,7 +6105,7 @@
       </p:sp>
       <p:sp>
         <p:nvSpPr>
-          <p:cNvPr id="227" name="Text 43"/>
+          <p:cNvPr id="226" name="Text 43"/>
           <p:cNvSpPr/>
           <p:nvPr/>
         </p:nvSpPr>
@@ -6155,7 +6166,7 @@
       </p:sp>
       <p:sp>
         <p:nvSpPr>
-          <p:cNvPr id="228" name="Text 44"/>
+          <p:cNvPr id="227" name="Text 44"/>
           <p:cNvSpPr/>
           <p:nvPr/>
         </p:nvSpPr>
@@ -6216,7 +6227,7 @@
       </p:sp>
       <p:sp>
         <p:nvSpPr>
-          <p:cNvPr id="229" name="Text 45"/>
+          <p:cNvPr id="228" name="Text 45"/>
           <p:cNvSpPr/>
           <p:nvPr/>
         </p:nvSpPr>
@@ -6277,7 +6288,7 @@
       </p:sp>
       <p:sp>
         <p:nvSpPr>
-          <p:cNvPr id="230" name="Shape 46"/>
+          <p:cNvPr id="229" name="Shape 46"/>
           <p:cNvSpPr/>
           <p:nvPr/>
         </p:nvSpPr>
@@ -6322,7 +6333,7 @@
       </p:sp>
       <p:sp>
         <p:nvSpPr>
-          <p:cNvPr id="231" name="Text 47"/>
+          <p:cNvPr id="230" name="Text 47"/>
           <p:cNvSpPr/>
           <p:nvPr/>
         </p:nvSpPr>
@@ -6383,7 +6394,7 @@
       </p:sp>
       <p:sp>
         <p:nvSpPr>
-          <p:cNvPr id="232" name="Text 48"/>
+          <p:cNvPr id="231" name="Text 48"/>
           <p:cNvSpPr/>
           <p:nvPr/>
         </p:nvSpPr>
@@ -6444,7 +6455,7 @@
       </p:sp>
       <p:sp>
         <p:nvSpPr>
-          <p:cNvPr id="233" name="Text 49"/>
+          <p:cNvPr id="232" name="Text 49"/>
           <p:cNvSpPr/>
           <p:nvPr/>
         </p:nvSpPr>
@@ -6505,7 +6516,7 @@
       </p:sp>
       <p:sp>
         <p:nvSpPr>
-          <p:cNvPr id="234" name="Text 50"/>
+          <p:cNvPr id="233" name="Text 50"/>
           <p:cNvSpPr/>
           <p:nvPr/>
         </p:nvSpPr>
@@ -6566,7 +6577,7 @@
       </p:sp>
       <p:sp>
         <p:nvSpPr>
-          <p:cNvPr id="235" name="Shape 51"/>
+          <p:cNvPr id="234" name="Shape 51"/>
           <p:cNvSpPr/>
           <p:nvPr/>
         </p:nvSpPr>
@@ -6611,7 +6622,7 @@
       </p:sp>
       <p:sp>
         <p:nvSpPr>
-          <p:cNvPr id="236" name="Text 52"/>
+          <p:cNvPr id="235" name="Text 52"/>
           <p:cNvSpPr/>
           <p:nvPr/>
         </p:nvSpPr>
@@ -6672,7 +6683,7 @@
       </p:sp>
       <p:sp>
         <p:nvSpPr>
-          <p:cNvPr id="237" name="Text 53"/>
+          <p:cNvPr id="236" name="Text 53"/>
           <p:cNvSpPr/>
           <p:nvPr/>
         </p:nvSpPr>
@@ -6733,7 +6744,7 @@
       </p:sp>
       <p:sp>
         <p:nvSpPr>
-          <p:cNvPr id="238" name="Text 54"/>
+          <p:cNvPr id="237" name="Text 54"/>
           <p:cNvSpPr/>
           <p:nvPr/>
         </p:nvSpPr>
@@ -6794,7 +6805,7 @@
       </p:sp>
       <p:sp>
         <p:nvSpPr>
-          <p:cNvPr id="239" name="Text 55"/>
+          <p:cNvPr id="238" name="Text 55"/>
           <p:cNvSpPr/>
           <p:nvPr/>
         </p:nvSpPr>
@@ -6855,7 +6866,7 @@
       </p:sp>
       <p:sp>
         <p:nvSpPr>
-          <p:cNvPr id="240" name="Shape 56"/>
+          <p:cNvPr id="239" name="Shape 56"/>
           <p:cNvSpPr/>
           <p:nvPr/>
         </p:nvSpPr>
@@ -6900,7 +6911,7 @@
       </p:sp>
       <p:sp>
         <p:nvSpPr>
-          <p:cNvPr id="241" name="Text 57"/>
+          <p:cNvPr id="240" name="Text 57"/>
           <p:cNvSpPr/>
           <p:nvPr/>
         </p:nvSpPr>
@@ -6961,7 +6972,7 @@
       </p:sp>
       <p:sp>
         <p:nvSpPr>
-          <p:cNvPr id="242" name="Text 58"/>
+          <p:cNvPr id="241" name="Text 58"/>
           <p:cNvSpPr/>
           <p:nvPr/>
         </p:nvSpPr>
@@ -7022,7 +7033,7 @@
       </p:sp>
       <p:sp>
         <p:nvSpPr>
-          <p:cNvPr id="243" name="Text 59"/>
+          <p:cNvPr id="242" name="Text 59"/>
           <p:cNvSpPr/>
           <p:nvPr/>
         </p:nvSpPr>
@@ -7083,7 +7094,7 @@
       </p:sp>
       <p:sp>
         <p:nvSpPr>
-          <p:cNvPr id="244" name="Text 60"/>
+          <p:cNvPr id="243" name="Text 60"/>
           <p:cNvSpPr/>
           <p:nvPr/>
         </p:nvSpPr>
@@ -7144,7 +7155,7 @@
       </p:sp>
       <p:sp>
         <p:nvSpPr>
-          <p:cNvPr id="245" name="Text 61"/>
+          <p:cNvPr id="244" name="Text 61"/>
           <p:cNvSpPr/>
           <p:nvPr/>
         </p:nvSpPr>
@@ -7205,7 +7216,7 @@
       </p:sp>
       <p:sp>
         <p:nvSpPr>
-          <p:cNvPr id="246" name="Text 62"/>
+          <p:cNvPr id="245" name="Text 62"/>
           <p:cNvSpPr/>
           <p:nvPr/>
         </p:nvSpPr>
@@ -7266,7 +7277,7 @@
       </p:sp>
       <p:sp>
         <p:nvSpPr>
-          <p:cNvPr id="247" name="Text 63"/>
+          <p:cNvPr id="246" name="Text 63"/>
           <p:cNvSpPr/>
           <p:nvPr/>
         </p:nvSpPr>
@@ -7327,7 +7338,7 @@
       </p:sp>
       <p:sp>
         <p:nvSpPr>
-          <p:cNvPr id="248" name="Text 64"/>
+          <p:cNvPr id="247" name="Text 64"/>
           <p:cNvSpPr/>
           <p:nvPr/>
         </p:nvSpPr>
@@ -7388,7 +7399,7 @@
       </p:sp>
       <p:sp>
         <p:nvSpPr>
-          <p:cNvPr id="249" name="Text 65"/>
+          <p:cNvPr id="248" name="Text 65"/>
           <p:cNvSpPr/>
           <p:nvPr/>
         </p:nvSpPr>
@@ -7449,7 +7460,7 @@
       </p:sp>
       <p:sp>
         <p:nvSpPr>
-          <p:cNvPr id="250" name="Text 66"/>
+          <p:cNvPr id="249" name="Text 66"/>
           <p:cNvSpPr/>
           <p:nvPr/>
         </p:nvSpPr>
@@ -7510,7 +7521,7 @@
       </p:sp>
       <p:sp>
         <p:nvSpPr>
-          <p:cNvPr id="251" name="Text 67"/>
+          <p:cNvPr id="250" name="Text 67"/>
           <p:cNvSpPr/>
           <p:nvPr/>
         </p:nvSpPr>
@@ -7571,7 +7582,7 @@
       </p:sp>
       <p:sp>
         <p:nvSpPr>
-          <p:cNvPr id="252" name="Text 68"/>
+          <p:cNvPr id="251" name="Text 68"/>
           <p:cNvSpPr/>
           <p:nvPr/>
         </p:nvSpPr>
@@ -7632,7 +7643,7 @@
       </p:sp>
       <p:sp>
         <p:nvSpPr>
-          <p:cNvPr id="253" name="Text 69"/>
+          <p:cNvPr id="252" name="Text 69"/>
           <p:cNvSpPr/>
           <p:nvPr/>
         </p:nvSpPr>
@@ -7693,7 +7704,7 @@
       </p:sp>
       <p:sp>
         <p:nvSpPr>
-          <p:cNvPr id="254" name="Text 70"/>
+          <p:cNvPr id="253" name="Text 70"/>
           <p:cNvSpPr/>
           <p:nvPr/>
         </p:nvSpPr>
@@ -7754,7 +7765,7 @@
       </p:sp>
       <p:sp>
         <p:nvSpPr>
-          <p:cNvPr id="255" name="Text 71"/>
+          <p:cNvPr id="254" name="Text 71"/>
           <p:cNvSpPr/>
           <p:nvPr/>
         </p:nvSpPr>
@@ -7815,7 +7826,7 @@
       </p:sp>
       <p:sp>
         <p:nvSpPr>
-          <p:cNvPr id="256" name="Text 72"/>
+          <p:cNvPr id="255" name="Text 72"/>
           <p:cNvSpPr/>
           <p:nvPr/>
         </p:nvSpPr>
@@ -7876,7 +7887,7 @@
       </p:sp>
       <p:sp>
         <p:nvSpPr>
-          <p:cNvPr id="257" name="Text 73"/>
+          <p:cNvPr id="256" name="Text 73"/>
           <p:cNvSpPr/>
           <p:nvPr/>
         </p:nvSpPr>
@@ -7974,7 +7985,7 @@
       </p:grpSpPr>
       <p:sp>
         <p:nvSpPr>
-          <p:cNvPr id="258" name="Shape 0"/>
+          <p:cNvPr id="257" name="Shape 0"/>
           <p:cNvSpPr/>
           <p:nvPr/>
         </p:nvSpPr>
@@ -8017,13 +8028,13 @@
       </p:sp>
       <p:sp>
         <p:nvSpPr>
-          <p:cNvPr id="259" name="Text 1"/>
-          <p:cNvSpPr/>
-          <p:nvPr/>
-        </p:nvSpPr>
-        <p:spPr>
-          <a:xfrm>
-            <a:off x="1119600" y="798120"/>
+          <p:cNvPr id="258" name="Text 1"/>
+          <p:cNvSpPr/>
+          <p:nvPr/>
+        </p:nvSpPr>
+        <p:spPr>
+          <a:xfrm>
+            <a:off x="1047600" y="762120"/>
             <a:ext cx="533160" cy="495000"/>
           </a:xfrm>
           <a:prstGeom prst="rect">
@@ -8078,7 +8089,7 @@
       </p:sp>
       <p:sp>
         <p:nvSpPr>
-          <p:cNvPr id="260" name="Text 2"/>
+          <p:cNvPr id="259" name="Text 2"/>
           <p:cNvSpPr/>
           <p:nvPr/>
         </p:nvSpPr>
@@ -8141,7 +8152,7 @@
       </p:sp>
       <p:sp>
         <p:nvSpPr>
-          <p:cNvPr id="261" name="Text 3"/>
+          <p:cNvPr id="260" name="Text 3"/>
           <p:cNvSpPr/>
           <p:nvPr/>
         </p:nvSpPr>
@@ -8204,7 +8215,7 @@
       </p:sp>
       <p:sp>
         <p:nvSpPr>
-          <p:cNvPr id="262" name="Text 4"/>
+          <p:cNvPr id="261" name="Text 4"/>
           <p:cNvSpPr/>
           <p:nvPr/>
         </p:nvSpPr>
@@ -8267,7 +8278,7 @@
       </p:sp>
       <p:sp>
         <p:nvSpPr>
-          <p:cNvPr id="263" name="Text 5"/>
+          <p:cNvPr id="262" name="Text 5"/>
           <p:cNvSpPr/>
           <p:nvPr/>
         </p:nvSpPr>
@@ -8340,7 +8351,7 @@
       </p:sp>
       <p:sp>
         <p:nvSpPr>
-          <p:cNvPr id="264" name="Text 6"/>
+          <p:cNvPr id="263" name="Text 6"/>
           <p:cNvSpPr/>
           <p:nvPr/>
         </p:nvSpPr>
@@ -8403,7 +8414,7 @@
       </p:sp>
       <p:sp>
         <p:nvSpPr>
-          <p:cNvPr id="265" name="Text 7"/>
+          <p:cNvPr id="264" name="Text 7"/>
           <p:cNvSpPr/>
           <p:nvPr/>
         </p:nvSpPr>
@@ -8554,7 +8565,7 @@
       </p:sp>
       <p:sp>
         <p:nvSpPr>
-          <p:cNvPr id="266" name="Shape 8"/>
+          <p:cNvPr id="265" name="Shape 8"/>
           <p:cNvSpPr/>
           <p:nvPr/>
         </p:nvSpPr>
@@ -8599,7 +8610,7 @@
       </p:sp>
       <p:sp>
         <p:nvSpPr>
-          <p:cNvPr id="267" name="Shape 9"/>
+          <p:cNvPr id="266" name="Shape 9"/>
           <p:cNvSpPr/>
           <p:nvPr/>
         </p:nvSpPr>
@@ -8642,7 +8653,7 @@
       </p:sp>
       <p:pic>
         <p:nvPicPr>
-          <p:cNvPr id="268" name="Image 0" descr="preencoded.png"/>
+          <p:cNvPr id="267" name="Image 0" descr="preencoded.png"/>
           <p:cNvPicPr/>
           <p:nvPr/>
         </p:nvPicPr>
@@ -8666,7 +8677,7 @@
       </p:pic>
       <p:sp>
         <p:nvSpPr>
-          <p:cNvPr id="269" name="Text 10"/>
+          <p:cNvPr id="268" name="Text 10"/>
           <p:cNvSpPr/>
           <p:nvPr/>
         </p:nvSpPr>
@@ -8729,7 +8740,7 @@
       </p:sp>
       <p:sp>
         <p:nvSpPr>
-          <p:cNvPr id="270" name="Text 11"/>
+          <p:cNvPr id="269" name="Text 11"/>
           <p:cNvSpPr/>
           <p:nvPr/>
         </p:nvSpPr>
@@ -8790,7 +8801,7 @@
       </p:sp>
       <p:sp>
         <p:nvSpPr>
-          <p:cNvPr id="271" name="Text 12"/>
+          <p:cNvPr id="270" name="Text 12"/>
           <p:cNvSpPr/>
           <p:nvPr/>
         </p:nvSpPr>
@@ -8853,7 +8864,7 @@
       </p:sp>
       <p:sp>
         <p:nvSpPr>
-          <p:cNvPr id="272" name="Text 13"/>
+          <p:cNvPr id="271" name="Text 13"/>
           <p:cNvSpPr/>
           <p:nvPr/>
         </p:nvSpPr>
@@ -8916,7 +8927,7 @@
       </p:sp>
       <p:sp>
         <p:nvSpPr>
-          <p:cNvPr id="273" name="Shape 14"/>
+          <p:cNvPr id="272" name="Shape 14"/>
           <p:cNvSpPr/>
           <p:nvPr/>
         </p:nvSpPr>
@@ -8961,7 +8972,7 @@
       </p:sp>
       <p:sp>
         <p:nvSpPr>
-          <p:cNvPr id="274" name="Text 15"/>
+          <p:cNvPr id="273" name="Text 15"/>
           <p:cNvSpPr/>
           <p:nvPr/>
         </p:nvSpPr>
@@ -9024,7 +9035,7 @@
       </p:sp>
       <p:sp>
         <p:nvSpPr>
-          <p:cNvPr id="275" name="Text 16"/>
+          <p:cNvPr id="274" name="Text 16"/>
           <p:cNvSpPr/>
           <p:nvPr/>
         </p:nvSpPr>
@@ -9070,31 +9081,7 @@
                 <a:latin typeface="Georgia"/>
                 <a:ea typeface="Georgia"/>
               </a:rPr>
-              <a:t>Rob </a:t>
-            </a:r>
-            <a:r>
-              <a:rPr lang="en-US" sz="3450" b="0" u="none" spc="-34" strike="noStrike">
-                <a:solidFill>
-                  <a:srgbClr val="F3ECE0"/>
-                </a:solidFill>
-                <a:effectLst/>
-                <a:uFillTx/>
-                <a:latin typeface="Georgia"/>
-                <a:ea typeface="Georgia"/>
-              </a:rPr>
-              <a:t>Oudend</a:t>
-            </a:r>
-            <a:r>
-              <a:rPr lang="en-US" sz="3450" b="0" u="none" spc="-34" strike="noStrike">
-                <a:solidFill>
-                  <a:srgbClr val="F3ECE0"/>
-                </a:solidFill>
-                <a:effectLst/>
-                <a:uFillTx/>
-                <a:latin typeface="Georgia"/>
-                <a:ea typeface="Georgia"/>
-              </a:rPr>
-              <a:t>ijk</a:t>
+              <a:t>Rob Oudendijk</a:t>
             </a:r>
             <a:endParaRPr lang="en-US" sz="3450" b="0" u="none" strike="noStrike">
               <a:solidFill>
@@ -9109,7 +9096,7 @@
       </p:sp>
       <p:sp>
         <p:nvSpPr>
-          <p:cNvPr id="276" name="Text 17"/>
+          <p:cNvPr id="275" name="Text 17"/>
           <p:cNvSpPr/>
           <p:nvPr/>
         </p:nvSpPr>
@@ -9172,7 +9159,7 @@
       </p:sp>
       <p:sp>
         <p:nvSpPr>
-          <p:cNvPr id="277" name="Text 18"/>
+          <p:cNvPr id="276" name="Text 18"/>
           <p:cNvSpPr/>
           <p:nvPr/>
         </p:nvSpPr>
@@ -9235,7 +9222,7 @@
       </p:sp>
       <p:sp>
         <p:nvSpPr>
-          <p:cNvPr id="278" name="Text 19"/>
+          <p:cNvPr id="277" name="Text 19"/>
           <p:cNvSpPr/>
           <p:nvPr/>
         </p:nvSpPr>
@@ -9398,7 +9385,7 @@
         </p:nvSpPr>
         <p:spPr>
           <a:xfrm>
-            <a:off x="1107000" y="798120"/>
+            <a:off x="1047600" y="762120"/>
             <a:ext cx="533160" cy="495000"/>
           </a:xfrm>
           <a:prstGeom prst="rect">
@@ -9560,7 +9547,19 @@
                 <a:latin typeface="Courier New"/>
                 <a:ea typeface="Courier New"/>
               </a:rPr>
-              <a:t>§ 01 · THE SETTING</a:t>
+              <a:t>§ 01 · THE </a:t>
+            </a:r>
+            <a:r>
+              <a:rPr lang="en-US" sz="1800" b="0" u="none" spc="145" strike="noStrike">
+                <a:solidFill>
+                  <a:srgbClr val="4C554F"/>
+                </a:solidFill>
+                <a:effectLst/>
+                <a:uFillTx/>
+                <a:latin typeface="Courier New"/>
+                <a:ea typeface="Courier New"/>
+              </a:rPr>
+              <a:t>SETTING</a:t>
             </a:r>
             <a:endParaRPr lang="en-US" sz="1800" b="0" u="none" strike="noStrike">
               <a:solidFill>
@@ -9654,8 +9653,8 @@
         </p:nvSpPr>
         <p:spPr>
           <a:xfrm>
-            <a:off x="1047600" y="2228760"/>
-            <a:ext cx="8325000" cy="5275080"/>
+            <a:off x="1047600" y="1828800"/>
+            <a:ext cx="7946280" cy="5275080"/>
           </a:xfrm>
           <a:prstGeom prst="rect">
             <a:avLst/>
@@ -9685,7 +9684,7 @@
               </a:tabLst>
             </a:pPr>
             <a:r>
-              <a:rPr lang="en-US" sz="8000" b="0" u="none" spc="-85" strike="noStrike">
+              <a:rPr lang="en-US" sz="8400" b="0" u="none" spc="-85" strike="noStrike">
                 <a:solidFill>
                   <a:srgbClr val="1F2A24"/>
                 </a:solidFill>
@@ -9697,7 +9696,7 @@
               <a:t>One closed school. One </a:t>
             </a:r>
             <a:r>
-              <a:rPr lang="en-US" sz="8000" b="0" i="1" u="none" spc="-85" strike="noStrike">
+              <a:rPr lang="en-US" sz="8400" b="0" i="1" u="none" spc="-85" strike="noStrike">
                 <a:solidFill>
                   <a:srgbClr val="C4663A"/>
                 </a:solidFill>
@@ -9706,21 +9705,33 @@
                 <a:latin typeface="Georgia"/>
                 <a:ea typeface="Georgia"/>
               </a:rPr>
-              <a:t>tired forest. </a:t>
-            </a:r>
-            <a:r>
-              <a:rPr lang="en-US" sz="8000" b="0" u="none" spc="-85" strike="noStrike">
-                <a:solidFill>
-                  <a:srgbClr val="1F2A24"/>
+              <a:t>tired </a:t>
+            </a:r>
+            <a:r>
+              <a:rPr lang="en-US" sz="8400" b="0" i="1" u="none" spc="-85" strike="noStrike">
+                <a:solidFill>
+                  <a:srgbClr val="C4663A"/>
                 </a:solidFill>
                 <a:effectLst/>
                 <a:uFillTx/>
                 <a:latin typeface="Georgia"/>
                 <a:ea typeface="Georgia"/>
               </a:rPr>
+              <a:t>forest. </a:t>
+            </a:r>
+            <a:r>
+              <a:rPr lang="en-US" sz="8400" b="0" u="none" spc="-85" strike="noStrike">
+                <a:solidFill>
+                  <a:srgbClr val="1F2A24"/>
+                </a:solidFill>
+                <a:effectLst/>
+                <a:uFillTx/>
+                <a:latin typeface="Georgia"/>
+                <a:ea typeface="Georgia"/>
+              </a:rPr>
               <a:t>One short list of ideas.</a:t>
             </a:r>
-            <a:endParaRPr lang="en-US" sz="8000" b="0" u="none" strike="noStrike">
+            <a:endParaRPr lang="en-US" sz="8400" b="0" u="none" strike="noStrike">
               <a:solidFill>
                 <a:srgbClr val="000000"/>
               </a:solidFill>
@@ -9739,7 +9750,7 @@
         </p:nvSpPr>
         <p:spPr>
           <a:xfrm>
-            <a:off x="1047600" y="7751880"/>
+            <a:off x="1047600" y="6858000"/>
             <a:ext cx="7946280" cy="1584720"/>
           </a:xfrm>
           <a:prstGeom prst="rect">
@@ -9779,7 +9790,31 @@
                 <a:latin typeface="Arial"/>
                 <a:ea typeface="Arial"/>
               </a:rPr>
-              <a:t>Mitsue is a mountain village in Nara Prefecture. The elementary school closed. The cedar plantations around it are old and unmanaged. The grid is fragile. None of this is unusual in rural Japan — that's the whole point.</a:t>
+              <a:t>Mitsue is a mountain village in Nara Prefecture. The elementary school closed. The cedar plantations </a:t>
+            </a:r>
+            <a:r>
+              <a:rPr lang="en-US" sz="2100" b="0" u="none" strike="noStrike">
+                <a:solidFill>
+                  <a:srgbClr val="1F2A24"/>
+                </a:solidFill>
+                <a:effectLst/>
+                <a:uFillTx/>
+                <a:latin typeface="Arial"/>
+                <a:ea typeface="Arial"/>
+              </a:rPr>
+              <a:t>around it are old and unmanaged. The grid is fragile. None of this is unusual in rural Japan — that's the </a:t>
+            </a:r>
+            <a:r>
+              <a:rPr lang="en-US" sz="2100" b="0" u="none" strike="noStrike">
+                <a:solidFill>
+                  <a:srgbClr val="1F2A24"/>
+                </a:solidFill>
+                <a:effectLst/>
+                <a:uFillTx/>
+                <a:latin typeface="Arial"/>
+                <a:ea typeface="Arial"/>
+              </a:rPr>
+              <a:t>whole point.</a:t>
             </a:r>
             <a:endParaRPr lang="en-US" sz="2100" b="0" u="none" strike="noStrike">
               <a:solidFill>
@@ -9800,7 +9835,7 @@
         </p:nvSpPr>
         <p:spPr>
           <a:xfrm>
-            <a:off x="1047600" y="9565200"/>
+            <a:off x="1143000" y="8229600"/>
             <a:ext cx="7946280" cy="811080"/>
           </a:xfrm>
           <a:prstGeom prst="rect">
@@ -9840,7 +9875,7 @@
                 <a:latin typeface="Arial"/>
                 <a:ea typeface="Arial"/>
               </a:rPr>
-              <a:t>If a small, careful intervention works here, it </a:t>
+              <a:t>If a small, careful intervention works here, it should be copy-pasteable into a </a:t>
             </a:r>
             <a:r>
               <a:rPr lang="en-US" sz="2100" b="0" u="none" strike="noStrike">
@@ -9852,19 +9887,7 @@
                 <a:latin typeface="Arial"/>
                 <a:ea typeface="Arial"/>
               </a:rPr>
-              <a:t>should be copy-pasteable into a thousand other </a:t>
-            </a:r>
-            <a:r>
-              <a:rPr lang="en-US" sz="2100" b="0" u="none" strike="noStrike">
-                <a:solidFill>
-                  <a:srgbClr val="4C554F"/>
-                </a:solidFill>
-                <a:effectLst/>
-                <a:uFillTx/>
-                <a:latin typeface="Arial"/>
-                <a:ea typeface="Arial"/>
-              </a:rPr>
-              <a:t>villages with the same pattern.</a:t>
+              <a:t>thousand other villages with the same pattern.</a:t>
             </a:r>
             <a:endParaRPr lang="en-US" sz="2100" b="0" u="none" strike="noStrike">
               <a:solidFill>
@@ -9885,7 +9908,7 @@
         </p:nvSpPr>
         <p:spPr>
           <a:xfrm>
-            <a:off x="9524880" y="5072040"/>
+            <a:off x="9655920" y="2391480"/>
             <a:ext cx="7714800" cy="5094720"/>
           </a:xfrm>
           <a:prstGeom prst="rect">
@@ -9931,7 +9954,7 @@
         </p:nvSpPr>
         <p:spPr>
           <a:xfrm>
-            <a:off x="9877320" y="5424480"/>
+            <a:off x="10008360" y="2743920"/>
             <a:ext cx="7220520" cy="380520"/>
           </a:xfrm>
           <a:prstGeom prst="rect">
@@ -10004,7 +10027,7 @@
         </p:nvSpPr>
         <p:spPr>
           <a:xfrm>
-            <a:off x="9877320" y="5938920"/>
+            <a:off x="10008360" y="3258360"/>
             <a:ext cx="7220520" cy="1561680"/>
           </a:xfrm>
           <a:prstGeom prst="rect">
@@ -10065,7 +10088,7 @@
         </p:nvSpPr>
         <p:spPr>
           <a:xfrm>
-            <a:off x="9877320" y="7767720"/>
+            <a:off x="10008360" y="5087160"/>
             <a:ext cx="7009920" cy="9000"/>
           </a:xfrm>
           <a:prstGeom prst="rect">
@@ -10110,7 +10133,7 @@
         </p:nvSpPr>
         <p:spPr>
           <a:xfrm>
-            <a:off x="9877320" y="8082000"/>
+            <a:off x="10008360" y="5401440"/>
             <a:ext cx="3492360" cy="304560"/>
           </a:xfrm>
           <a:prstGeom prst="rect">
@@ -10171,7 +10194,7 @@
         </p:nvSpPr>
         <p:spPr>
           <a:xfrm>
-            <a:off x="9877320" y="8348760"/>
+            <a:off x="10008360" y="5668200"/>
             <a:ext cx="3492360" cy="523080"/>
           </a:xfrm>
           <a:prstGeom prst="rect">
@@ -10232,7 +10255,7 @@
         </p:nvSpPr>
         <p:spPr>
           <a:xfrm>
-            <a:off x="13496760" y="8082000"/>
+            <a:off x="13627800" y="5401440"/>
             <a:ext cx="3492360" cy="304560"/>
           </a:xfrm>
           <a:prstGeom prst="rect">
@@ -10293,7 +10316,7 @@
         </p:nvSpPr>
         <p:spPr>
           <a:xfrm>
-            <a:off x="13496760" y="8348760"/>
+            <a:off x="13627800" y="5668200"/>
             <a:ext cx="3492360" cy="523080"/>
           </a:xfrm>
           <a:prstGeom prst="rect">
@@ -10354,7 +10377,7 @@
         </p:nvSpPr>
         <p:spPr>
           <a:xfrm>
-            <a:off x="9877320" y="9062640"/>
+            <a:off x="10008360" y="6382080"/>
             <a:ext cx="3492360" cy="304560"/>
           </a:xfrm>
           <a:prstGeom prst="rect">
@@ -10415,7 +10438,7 @@
         </p:nvSpPr>
         <p:spPr>
           <a:xfrm>
-            <a:off x="9877320" y="9329400"/>
+            <a:off x="10008360" y="6648840"/>
             <a:ext cx="3492360" cy="523080"/>
           </a:xfrm>
           <a:prstGeom prst="rect">
@@ -10476,7 +10499,7 @@
         </p:nvSpPr>
         <p:spPr>
           <a:xfrm>
-            <a:off x="13496760" y="9062640"/>
+            <a:off x="13627800" y="6382080"/>
             <a:ext cx="3492360" cy="304560"/>
           </a:xfrm>
           <a:prstGeom prst="rect">
@@ -10537,7 +10560,7 @@
         </p:nvSpPr>
         <p:spPr>
           <a:xfrm>
-            <a:off x="13496760" y="9329400"/>
+            <a:off x="13627800" y="6648840"/>
             <a:ext cx="3492360" cy="523080"/>
           </a:xfrm>
           <a:prstGeom prst="rect">
@@ -10598,7 +10621,7 @@
         </p:nvSpPr>
         <p:spPr>
           <a:xfrm>
-            <a:off x="9524880" y="10338840"/>
+            <a:off x="8993880" y="9565200"/>
             <a:ext cx="7946280" cy="304560"/>
           </a:xfrm>
           <a:prstGeom prst="rect">
@@ -10638,7 +10661,19 @@
                 <a:latin typeface="Courier New"/>
                 <a:ea typeface="Courier New"/>
               </a:rPr>
-              <a:t>RURAL REVITALIZATION, BUT QUIETLY.</a:t>
+              <a:t>RURAL REVITALIZATION, BUT </a:t>
+            </a:r>
+            <a:r>
+              <a:rPr lang="en-US" sz="1800" b="0" u="none" spc="215" strike="noStrike">
+                <a:solidFill>
+                  <a:srgbClr val="4C554F"/>
+                </a:solidFill>
+                <a:effectLst/>
+                <a:uFillTx/>
+                <a:latin typeface="Courier New"/>
+                <a:ea typeface="Courier New"/>
+              </a:rPr>
+              <a:t>QUIETLY.</a:t>
             </a:r>
             <a:endParaRPr lang="en-US" sz="1800" b="0" u="none" strike="noStrike">
               <a:solidFill>
@@ -10659,7 +10694,7 @@
         </p:nvSpPr>
         <p:spPr>
           <a:xfrm>
-            <a:off x="1047600" y="10605600"/>
+            <a:off x="1143000" y="9525240"/>
             <a:ext cx="1154520" cy="304560"/>
           </a:xfrm>
           <a:prstGeom prst="rect">
@@ -10720,7 +10755,7 @@
         </p:nvSpPr>
         <p:spPr>
           <a:xfrm>
-            <a:off x="15850800" y="10605600"/>
+            <a:off x="16137000" y="9525240"/>
             <a:ext cx="1465200" cy="304560"/>
           </a:xfrm>
           <a:prstGeom prst="rect">
@@ -10861,7 +10896,7 @@
         </p:nvSpPr>
         <p:spPr>
           <a:xfrm>
-            <a:off x="1107000" y="798120"/>
+            <a:off x="1047600" y="762120"/>
             <a:ext cx="533160" cy="495000"/>
           </a:xfrm>
           <a:prstGeom prst="rect">
@@ -11023,7 +11058,19 @@
                 <a:latin typeface="Courier New"/>
                 <a:ea typeface="Courier New"/>
               </a:rPr>
-              <a:t>§ 02 · FOUR PRESSURES, ONE RURAL ANSWER</a:t>
+              <a:t>§ 02 · FOUR PRESSURES, ONE RURAL </a:t>
+            </a:r>
+            <a:r>
+              <a:rPr lang="en-US" sz="1800" b="0" u="none" spc="145" strike="noStrike">
+                <a:solidFill>
+                  <a:srgbClr val="4C554F"/>
+                </a:solidFill>
+                <a:effectLst/>
+                <a:uFillTx/>
+                <a:latin typeface="Courier New"/>
+                <a:ea typeface="Courier New"/>
+              </a:rPr>
+              <a:t>ANSWER</a:t>
             </a:r>
             <a:endParaRPr lang="en-US" sz="1800" b="0" u="none" strike="noStrike">
               <a:solidFill>
@@ -11084,18 +11131,42 @@
                 <a:latin typeface="Georgia"/>
                 <a:ea typeface="Georgia"/>
               </a:rPr>
-              <a:t>Four expensive problems that turn out to be </a:t>
-            </a:r>
-            <a:r>
-              <a:rPr lang="en-US" sz="7200" b="0" i="1" u="none" spc="-71" strike="noStrike">
-                <a:solidFill>
-                  <a:srgbClr val="C4663A"/>
+              <a:t>Four expensive </a:t>
+            </a:r>
+            <a:r>
+              <a:rPr lang="en-US" sz="7200" b="0" u="none" spc="-71" strike="noStrike">
+                <a:solidFill>
+                  <a:srgbClr val="1F2A24"/>
                 </a:solidFill>
                 <a:effectLst/>
                 <a:uFillTx/>
                 <a:latin typeface="Georgia"/>
                 <a:ea typeface="Georgia"/>
               </a:rPr>
+              <a:t>problems that turn out </a:t>
+            </a:r>
+            <a:r>
+              <a:rPr lang="en-US" sz="7200" b="0" u="none" spc="-71" strike="noStrike">
+                <a:solidFill>
+                  <a:srgbClr val="1F2A24"/>
+                </a:solidFill>
+                <a:effectLst/>
+                <a:uFillTx/>
+                <a:latin typeface="Georgia"/>
+                <a:ea typeface="Georgia"/>
+              </a:rPr>
+              <a:t>to be </a:t>
+            </a:r>
+            <a:r>
+              <a:rPr lang="en-US" sz="7200" b="0" i="1" u="none" spc="-71" strike="noStrike">
+                <a:solidFill>
+                  <a:srgbClr val="C4663A"/>
+                </a:solidFill>
+                <a:effectLst/>
+                <a:uFillTx/>
+                <a:latin typeface="Georgia"/>
+                <a:ea typeface="Georgia"/>
+              </a:rPr>
               <a:t>cheaper together.</a:t>
             </a:r>
             <a:endParaRPr lang="en-US" sz="7200" b="0" u="none" strike="noStrike">
@@ -11157,7 +11228,43 @@
                 <a:latin typeface="Noto Serif JP"/>
                 <a:ea typeface="Noto Serif JP"/>
               </a:rPr>
-              <a:t>四つの構造的圧力、ひとつの農村型解答</a:t>
+              <a:t>四つの構造</a:t>
+            </a:r>
+            <a:r>
+              <a:rPr lang="zh-CN" sz="2100" b="0" u="none" strike="noStrike">
+                <a:solidFill>
+                  <a:srgbClr val="4C554F"/>
+                </a:solidFill>
+                <a:effectLst/>
+                <a:uFillTx/>
+                <a:latin typeface="Noto Serif JP"/>
+                <a:ea typeface="Noto Serif JP"/>
+              </a:rPr>
+              <a:t>的圧力、ひ</a:t>
+            </a:r>
+            <a:r>
+              <a:rPr lang="zh-CN" sz="2100" b="0" u="none" strike="noStrike">
+                <a:solidFill>
+                  <a:srgbClr val="4C554F"/>
+                </a:solidFill>
+                <a:effectLst/>
+                <a:uFillTx/>
+                <a:latin typeface="Noto Serif JP"/>
+                <a:ea typeface="Noto Serif JP"/>
+              </a:rPr>
+              <a:t>とつの農村</a:t>
+            </a:r>
+            <a:r>
+              <a:rPr lang="zh-CN" sz="2100" b="0" u="none" strike="noStrike">
+                <a:solidFill>
+                  <a:srgbClr val="4C554F"/>
+                </a:solidFill>
+                <a:effectLst/>
+                <a:uFillTx/>
+                <a:latin typeface="Noto Serif JP"/>
+                <a:ea typeface="Noto Serif JP"/>
+              </a:rPr>
+              <a:t>型解答</a:t>
             </a:r>
             <a:endParaRPr lang="en-US" sz="2100" b="0" u="none" strike="noStrike">
               <a:solidFill>
@@ -11367,8 +11474,8 @@
         </p:nvSpPr>
         <p:spPr>
           <a:xfrm>
-            <a:off x="1047600" y="7135920"/>
-            <a:ext cx="3948480" cy="1695240"/>
+            <a:off x="1047600" y="7269840"/>
+            <a:ext cx="3948480" cy="1058760"/>
           </a:xfrm>
           <a:prstGeom prst="rect">
             <a:avLst/>
@@ -11386,7 +11493,7 @@
         </p:style>
         <p:txBody>
           <a:bodyPr lIns="25560" tIns="25560" rIns="25560" bIns="25560" anchor="t">
-            <a:normAutofit/>
+            <a:normAutofit fontScale="85000" lnSpcReduction="9999"/>
           </a:bodyPr>
           <a:p>
             <a:pPr defTabSz="914400">
@@ -11407,7 +11514,7 @@
                 <a:latin typeface="Arial"/>
                 <a:ea typeface="Arial"/>
               </a:rPr>
-              <a:t>≈ 10 years until most Japanese passenger vehicles are electric. Rural grids need new distributed generation. Extension is slow and expensive.</a:t>
+              <a:t>In the near future passenger vehicles will be  electric. Rural grids need new distributed generation. Extension is slow and expensive.</a:t>
             </a:r>
             <a:endParaRPr lang="en-US" sz="1800" b="0" u="none" strike="noStrike">
               <a:solidFill>
@@ -11557,7 +11664,7 @@
         <p:spPr>
           <a:xfrm>
             <a:off x="5167440" y="6411960"/>
-            <a:ext cx="3948480" cy="437760"/>
+            <a:ext cx="3948480" cy="837720"/>
           </a:xfrm>
           <a:prstGeom prst="rect">
             <a:avLst/>
@@ -11596,7 +11703,7 @@
                 <a:latin typeface="Georgia"/>
                 <a:ea typeface="Georgia"/>
               </a:rPr>
-              <a:t>Cedar is a liability.</a:t>
+              <a:t>Cedar is a liability — and a fuel.</a:t>
             </a:r>
             <a:endParaRPr lang="en-US" sz="3000" b="0" u="none" strike="noStrike">
               <a:solidFill>
@@ -11617,7 +11724,7 @@
         </p:nvSpPr>
         <p:spPr>
           <a:xfrm>
-            <a:off x="5167440" y="7135920"/>
+            <a:off x="5167440" y="7249680"/>
             <a:ext cx="3948480" cy="1363680"/>
           </a:xfrm>
           <a:prstGeom prst="rect">
@@ -11657,7 +11764,7 @@
                 <a:latin typeface="Arial"/>
                 <a:ea typeface="Arial"/>
               </a:rPr>
-              <a:t>Aged sugi plantations: pollen burden, biodiversity loss, landslide risk. Replacing them with native broadleaf converts a liability into a living forest.</a:t>
+              <a:t>Aged sugi plantations: pollen, biodiversity loss, landslide risk. Removing them powers the village; replacing them rebuilds the forest.</a:t>
             </a:r>
             <a:endParaRPr lang="en-US" sz="1800" b="0" u="none" strike="noStrike">
               <a:solidFill>
@@ -11867,7 +11974,7 @@
         </p:nvSpPr>
         <p:spPr>
           <a:xfrm>
-            <a:off x="9286920" y="7535880"/>
+            <a:off x="9286920" y="7249680"/>
             <a:ext cx="3948480" cy="1363680"/>
           </a:xfrm>
           <a:prstGeom prst="rect">
@@ -12117,7 +12224,7 @@
         </p:nvSpPr>
         <p:spPr>
           <a:xfrm>
-            <a:off x="13406400" y="7135920"/>
+            <a:off x="13425120" y="7251120"/>
             <a:ext cx="3948480" cy="1363680"/>
           </a:xfrm>
           <a:prstGeom prst="rect">
@@ -12380,7 +12487,7 @@
         </p:nvSpPr>
         <p:spPr>
           <a:xfrm>
-            <a:off x="1119600" y="798120"/>
+            <a:off x="1047600" y="762120"/>
             <a:ext cx="533160" cy="495000"/>
           </a:xfrm>
           <a:prstGeom prst="rect">
@@ -12567,7 +12674,7 @@
         </p:nvSpPr>
         <p:spPr>
           <a:xfrm>
-            <a:off x="1047600" y="1280880"/>
+            <a:off x="1047600" y="1219320"/>
             <a:ext cx="16678080" cy="304560"/>
           </a:xfrm>
           <a:prstGeom prst="rect">
@@ -12630,7 +12737,7 @@
         </p:nvSpPr>
         <p:spPr>
           <a:xfrm>
-            <a:off x="1047600" y="1852200"/>
+            <a:off x="1047600" y="1790640"/>
             <a:ext cx="16678080" cy="3676320"/>
           </a:xfrm>
           <a:prstGeom prst="rect">
@@ -12670,30 +12777,18 @@
                 <a:latin typeface="Georgia"/>
                 <a:ea typeface="Georgia"/>
               </a:rPr>
-              <a:t>Forest. Power. </a:t>
-            </a:r>
-            <a:r>
-              <a:rPr lang="en-US" sz="15000" b="0" u="none" spc="-150" strike="noStrike">
-                <a:solidFill>
-                  <a:srgbClr val="F3ECE0"/>
+              <a:t>Forest. Power. Compute. </a:t>
+            </a:r>
+            <a:r>
+              <a:rPr lang="en-US" sz="15000" b="0" i="1" u="none" spc="-150" strike="noStrike">
+                <a:solidFill>
+                  <a:srgbClr val="F3B486"/>
                 </a:solidFill>
                 <a:effectLst/>
                 <a:uFillTx/>
                 <a:latin typeface="Georgia"/>
                 <a:ea typeface="Georgia"/>
               </a:rPr>
-              <a:t>Compute. </a:t>
-            </a:r>
-            <a:r>
-              <a:rPr lang="en-US" sz="15000" b="0" i="1" u="none" spc="-150" strike="noStrike">
-                <a:solidFill>
-                  <a:srgbClr val="F3B486"/>
-                </a:solidFill>
-                <a:effectLst/>
-                <a:uFillTx/>
-                <a:latin typeface="Georgia"/>
-                <a:ea typeface="Georgia"/>
-              </a:rPr>
               <a:t>One ledger.</a:t>
             </a:r>
             <a:endParaRPr lang="en-US" sz="15000" b="0" u="none" strike="noStrike">
@@ -12715,7 +12810,7 @@
         </p:nvSpPr>
         <p:spPr>
           <a:xfrm>
-            <a:off x="1047600" y="5891040"/>
+            <a:off x="1047600" y="5829480"/>
             <a:ext cx="16678080" cy="542520"/>
           </a:xfrm>
           <a:prstGeom prst="rect">
@@ -12778,7 +12873,7 @@
         </p:nvSpPr>
         <p:spPr>
           <a:xfrm>
-            <a:off x="1047600" y="7157880"/>
+            <a:off x="1047600" y="7095960"/>
             <a:ext cx="5166720" cy="304560"/>
           </a:xfrm>
           <a:prstGeom prst="rect">
@@ -12841,7 +12936,7 @@
         </p:nvSpPr>
         <p:spPr>
           <a:xfrm>
-            <a:off x="1047600" y="7500600"/>
+            <a:off x="1047600" y="7439040"/>
             <a:ext cx="5166720" cy="647280"/>
           </a:xfrm>
           <a:prstGeom prst="rect">
@@ -12902,7 +12997,7 @@
         </p:nvSpPr>
         <p:spPr>
           <a:xfrm>
-            <a:off x="1047600" y="8243640"/>
+            <a:off x="1047600" y="8182080"/>
             <a:ext cx="5166720" cy="700560"/>
           </a:xfrm>
           <a:prstGeom prst="rect">
@@ -12965,7 +13060,7 @@
         </p:nvSpPr>
         <p:spPr>
           <a:xfrm>
-            <a:off x="6635880" y="7157880"/>
+            <a:off x="6635880" y="7095960"/>
             <a:ext cx="5166720" cy="304560"/>
           </a:xfrm>
           <a:prstGeom prst="rect">
@@ -13028,7 +13123,7 @@
         </p:nvSpPr>
         <p:spPr>
           <a:xfrm>
-            <a:off x="6635880" y="7500600"/>
+            <a:off x="6635880" y="7439040"/>
             <a:ext cx="5166720" cy="647280"/>
           </a:xfrm>
           <a:prstGeom prst="rect">
@@ -13089,8 +13184,8 @@
         </p:nvSpPr>
         <p:spPr>
           <a:xfrm>
-            <a:off x="6635880" y="8243640"/>
-            <a:ext cx="5166720" cy="700560"/>
+            <a:off x="6635880" y="8182080"/>
+            <a:ext cx="5166720" cy="1032120"/>
           </a:xfrm>
           <a:prstGeom prst="rect">
             <a:avLst/>
@@ -13108,7 +13203,7 @@
         </p:style>
         <p:txBody>
           <a:bodyPr lIns="25560" tIns="25560" rIns="25560" bIns="25560" anchor="t">
-            <a:normAutofit fontScale="85000" lnSpcReduction="9999"/>
+            <a:normAutofit fontScale="92500" lnSpcReduction="9999"/>
           </a:bodyPr>
           <a:p>
             <a:pPr defTabSz="914400">
@@ -13131,7 +13226,7 @@
                 <a:latin typeface="Arial"/>
                 <a:ea typeface="Arial"/>
               </a:rPr>
-              <a:t>Local solar + storage + EV chargers on one bus. Blackout resilience built in.</a:t>
+              <a:t>Sugi biomass (the trees we remove) + solar + storage. EV chargers and blackout resilience built in.</a:t>
             </a:r>
             <a:endParaRPr lang="en-US" sz="1800" b="0" u="none" strike="noStrike">
               <a:solidFill>
@@ -13152,7 +13247,7 @@
         </p:nvSpPr>
         <p:spPr>
           <a:xfrm>
-            <a:off x="12223800" y="7157880"/>
+            <a:off x="12223800" y="7095960"/>
             <a:ext cx="5166720" cy="304560"/>
           </a:xfrm>
           <a:prstGeom prst="rect">
@@ -13215,7 +13310,7 @@
         </p:nvSpPr>
         <p:spPr>
           <a:xfrm>
-            <a:off x="12223800" y="7500600"/>
+            <a:off x="12223800" y="7439040"/>
             <a:ext cx="5166720" cy="647280"/>
           </a:xfrm>
           <a:prstGeom prst="rect">
@@ -13276,7 +13371,7 @@
         </p:nvSpPr>
         <p:spPr>
           <a:xfrm>
-            <a:off x="12223800" y="8243640"/>
+            <a:off x="12223800" y="8182080"/>
             <a:ext cx="5166720" cy="700560"/>
           </a:xfrm>
           <a:prstGeom prst="rect">
@@ -13339,7 +13434,7 @@
         </p:nvSpPr>
         <p:spPr>
           <a:xfrm>
-            <a:off x="1047600" y="9258480"/>
+            <a:off x="1047600" y="9405000"/>
             <a:ext cx="1154520" cy="304560"/>
           </a:xfrm>
           <a:prstGeom prst="rect">
@@ -13402,7 +13497,7 @@
         </p:nvSpPr>
         <p:spPr>
           <a:xfrm>
-            <a:off x="7458120" y="9258480"/>
+            <a:off x="7458120" y="9405000"/>
             <a:ext cx="10074960" cy="304560"/>
           </a:xfrm>
           <a:prstGeom prst="rect">
@@ -13545,7 +13640,7 @@
         </p:nvSpPr>
         <p:spPr>
           <a:xfrm>
-            <a:off x="1119600" y="798120"/>
+            <a:off x="1047600" y="762120"/>
             <a:ext cx="533160" cy="495000"/>
           </a:xfrm>
           <a:prstGeom prst="rect">
@@ -13741,7 +13836,80 @@
         <p:spPr>
           <a:xfrm>
             <a:off x="1047600" y="1695600"/>
-            <a:ext cx="8324640" cy="2968920"/>
+            <a:ext cx="8324640" cy="2511360"/>
+          </a:xfrm>
+          <a:prstGeom prst="rect">
+            <a:avLst/>
+          </a:prstGeom>
+          <a:noFill/>
+          <a:ln w="0">
+            <a:noFill/>
+          </a:ln>
+        </p:spPr>
+        <p:style>
+          <a:lnRef idx="0"/>
+          <a:fillRef idx="0"/>
+          <a:effectRef idx="0"/>
+          <a:fontRef idx="minor"/>
+        </p:style>
+        <p:txBody>
+          <a:bodyPr lIns="25560" tIns="25560" rIns="25560" bIns="25560" anchor="t">
+            <a:normAutofit/>
+          </a:bodyPr>
+          <a:p>
+            <a:pPr defTabSz="914400">
+              <a:lnSpc>
+                <a:spcPct val="97000"/>
+              </a:lnSpc>
+              <a:tabLst>
+                <a:tab pos="0" algn="l"/>
+              </a:tabLst>
+            </a:pPr>
+            <a:r>
+              <a:rPr lang="en-US" sz="6600" b="0" u="none" spc="-65" strike="noStrike">
+                <a:solidFill>
+                  <a:srgbClr val="1F2A24"/>
+                </a:solidFill>
+                <a:effectLst/>
+                <a:uFillTx/>
+                <a:latin typeface="Georgia"/>
+                <a:ea typeface="Georgia"/>
+              </a:rPr>
+              <a:t>We feed the bears, so the bears </a:t>
+            </a:r>
+            <a:r>
+              <a:rPr lang="en-US" sz="6600" b="0" i="1" u="none" spc="-65" strike="noStrike">
+                <a:solidFill>
+                  <a:srgbClr val="C4663A"/>
+                </a:solidFill>
+                <a:effectLst/>
+                <a:uFillTx/>
+                <a:latin typeface="Georgia"/>
+                <a:ea typeface="Georgia"/>
+              </a:rPr>
+              <a:t>stop visiting.</a:t>
+            </a:r>
+            <a:endParaRPr lang="en-US" sz="6600" b="0" u="none" strike="noStrike">
+              <a:solidFill>
+                <a:srgbClr val="000000"/>
+              </a:solidFill>
+              <a:effectLst/>
+              <a:uFillTx/>
+              <a:latin typeface="Arial"/>
+            </a:endParaRPr>
+          </a:p>
+        </p:txBody>
+      </p:sp>
+      <p:sp>
+        <p:nvSpPr>
+          <p:cNvPr id="94" name="Text 5"/>
+          <p:cNvSpPr/>
+          <p:nvPr/>
+        </p:nvSpPr>
+        <p:spPr>
+          <a:xfrm>
+            <a:off x="1047600" y="4340520"/>
+            <a:ext cx="8324640" cy="1584720"/>
           </a:xfrm>
           <a:prstGeom prst="rect">
             <a:avLst/>
@@ -13764,14 +13932,258 @@
           <a:p>
             <a:pPr defTabSz="914400">
               <a:lnSpc>
-                <a:spcPct val="97000"/>
-              </a:lnSpc>
-              <a:tabLst>
-                <a:tab pos="0" algn="l"/>
-              </a:tabLst>
-            </a:pPr>
-            <a:r>
-              <a:rPr lang="en-US" sz="7800" b="0" u="none" spc="-79" strike="noStrike">
+                <a:spcPct val="145000"/>
+              </a:lnSpc>
+              <a:tabLst>
+                <a:tab pos="0" algn="l"/>
+              </a:tabLst>
+            </a:pPr>
+            <a:r>
+              <a:rPr lang="en-US" sz="2100" b="0" u="none" strike="noStrike">
+                <a:solidFill>
+                  <a:srgbClr val="1F2A24"/>
+                </a:solidFill>
+                <a:effectLst/>
+                <a:uFillTx/>
+                <a:latin typeface="Arial"/>
+                <a:ea typeface="Arial"/>
+              </a:rPr>
+              <a:t>Phased replacement of aged sugi (cedar) plantations with native broadleaf — oak, chestnut, konara. Done with local landowners and the Forestry Agency. The 25-year arc is the ecological clock, not the funding cycle.</a:t>
+            </a:r>
+            <a:endParaRPr lang="en-US" sz="2100" b="0" u="none" strike="noStrike">
+              <a:solidFill>
+                <a:srgbClr val="000000"/>
+              </a:solidFill>
+              <a:effectLst/>
+              <a:uFillTx/>
+              <a:latin typeface="Arial"/>
+            </a:endParaRPr>
+          </a:p>
+        </p:txBody>
+      </p:sp>
+      <p:sp>
+        <p:nvSpPr>
+          <p:cNvPr id="95" name="Text 6"/>
+          <p:cNvSpPr/>
+          <p:nvPr/>
+        </p:nvSpPr>
+        <p:spPr>
+          <a:xfrm>
+            <a:off x="1047600" y="6154200"/>
+            <a:ext cx="8324640" cy="811080"/>
+          </a:xfrm>
+          <a:prstGeom prst="rect">
+            <a:avLst/>
+          </a:prstGeom>
+          <a:noFill/>
+          <a:ln w="0">
+            <a:noFill/>
+          </a:ln>
+        </p:spPr>
+        <p:style>
+          <a:lnRef idx="0"/>
+          <a:fillRef idx="0"/>
+          <a:effectRef idx="0"/>
+          <a:fontRef idx="minor"/>
+        </p:style>
+        <p:txBody>
+          <a:bodyPr lIns="25560" tIns="25560" rIns="25560" bIns="25560" anchor="t">
+            <a:normAutofit fontScale="92500" lnSpcReduction="9999"/>
+          </a:bodyPr>
+          <a:p>
+            <a:pPr defTabSz="914400">
+              <a:lnSpc>
+                <a:spcPct val="145000"/>
+              </a:lnSpc>
+              <a:tabLst>
+                <a:tab pos="0" algn="l"/>
+              </a:tabLst>
+            </a:pPr>
+            <a:r>
+              <a:rPr lang="en-US" sz="2100" b="0" u="none" strike="noStrike">
+                <a:solidFill>
+                  <a:srgbClr val="1F2A24"/>
+                </a:solidFill>
+                <a:effectLst/>
+                <a:uFillTx/>
+                <a:latin typeface="Arial"/>
+                <a:ea typeface="Arial"/>
+              </a:rPr>
+              <a:t>The sugi we remove doesn't go to waste — it becomes the village's primary biomass fuel. The forest pays for its own restoration.</a:t>
+            </a:r>
+            <a:endParaRPr lang="en-US" sz="2100" b="0" u="none" strike="noStrike">
+              <a:solidFill>
+                <a:srgbClr val="000000"/>
+              </a:solidFill>
+              <a:effectLst/>
+              <a:uFillTx/>
+              <a:latin typeface="Arial"/>
+            </a:endParaRPr>
+          </a:p>
+        </p:txBody>
+      </p:sp>
+      <p:sp>
+        <p:nvSpPr>
+          <p:cNvPr id="96" name="Text 7"/>
+          <p:cNvSpPr/>
+          <p:nvPr/>
+        </p:nvSpPr>
+        <p:spPr>
+          <a:xfrm>
+            <a:off x="1047600" y="7194240"/>
+            <a:ext cx="8324640" cy="1197720"/>
+          </a:xfrm>
+          <a:prstGeom prst="rect">
+            <a:avLst/>
+          </a:prstGeom>
+          <a:noFill/>
+          <a:ln w="0">
+            <a:noFill/>
+          </a:ln>
+        </p:spPr>
+        <p:style>
+          <a:lnRef idx="0"/>
+          <a:fillRef idx="0"/>
+          <a:effectRef idx="0"/>
+          <a:fontRef idx="minor"/>
+        </p:style>
+        <p:txBody>
+          <a:bodyPr lIns="25560" tIns="25560" rIns="25560" bIns="25560" anchor="t">
+            <a:normAutofit fontScale="92500" lnSpcReduction="9999"/>
+          </a:bodyPr>
+          <a:p>
+            <a:pPr defTabSz="914400">
+              <a:lnSpc>
+                <a:spcPct val="145000"/>
+              </a:lnSpc>
+              <a:tabLst>
+                <a:tab pos="0" algn="l"/>
+              </a:tabLst>
+            </a:pPr>
+            <a:r>
+              <a:rPr lang="en-US" sz="2100" b="0" u="none" strike="noStrike">
+                <a:solidFill>
+                  <a:srgbClr val="1F2A24"/>
+                </a:solidFill>
+                <a:effectLst/>
+                <a:uFillTx/>
+                <a:latin typeface="Arial"/>
+                <a:ea typeface="Arial"/>
+              </a:rPr>
+              <a:t>Broadleaf trees produce acorns and nuts that sustain deer, wild boar, and bear through winter. When the forest feeds them, they stay there — and out of the village vegetable patch.</a:t>
+            </a:r>
+            <a:endParaRPr lang="en-US" sz="2100" b="0" u="none" strike="noStrike">
+              <a:solidFill>
+                <a:srgbClr val="000000"/>
+              </a:solidFill>
+              <a:effectLst/>
+              <a:uFillTx/>
+              <a:latin typeface="Arial"/>
+            </a:endParaRPr>
+          </a:p>
+        </p:txBody>
+      </p:sp>
+      <p:sp>
+        <p:nvSpPr>
+          <p:cNvPr id="97" name="Text 9"/>
+          <p:cNvSpPr/>
+          <p:nvPr/>
+        </p:nvSpPr>
+        <p:spPr>
+          <a:xfrm>
+            <a:off x="1047600" y="8458200"/>
+            <a:ext cx="2579400" cy="304560"/>
+          </a:xfrm>
+          <a:prstGeom prst="rect">
+            <a:avLst/>
+          </a:prstGeom>
+          <a:noFill/>
+          <a:ln w="0">
+            <a:noFill/>
+          </a:ln>
+        </p:spPr>
+        <p:style>
+          <a:lnRef idx="0"/>
+          <a:fillRef idx="0"/>
+          <a:effectRef idx="0"/>
+          <a:fontRef idx="minor"/>
+        </p:style>
+        <p:txBody>
+          <a:bodyPr lIns="25560" tIns="25560" rIns="25560" bIns="25560" anchor="t">
+            <a:normAutofit lnSpcReduction="9999"/>
+          </a:bodyPr>
+          <a:p>
+            <a:pPr defTabSz="914400">
+              <a:lnSpc>
+                <a:spcPct val="100000"/>
+              </a:lnSpc>
+              <a:tabLst>
+                <a:tab pos="0" algn="l"/>
+              </a:tabLst>
+            </a:pPr>
+            <a:r>
+              <a:rPr lang="en-US" sz="1800" b="0" u="none" spc="215" strike="noStrike">
+                <a:solidFill>
+                  <a:srgbClr val="4C554F"/>
+                </a:solidFill>
+                <a:effectLst/>
+                <a:uFillTx/>
+                <a:latin typeface="Courier New"/>
+                <a:ea typeface="Courier New"/>
+              </a:rPr>
+              <a:t>POLLEN</a:t>
+            </a:r>
+            <a:endParaRPr lang="en-US" sz="1800" b="0" u="none" strike="noStrike">
+              <a:solidFill>
+                <a:srgbClr val="000000"/>
+              </a:solidFill>
+              <a:effectLst/>
+              <a:uFillTx/>
+              <a:latin typeface="Arial"/>
+            </a:endParaRPr>
+          </a:p>
+        </p:txBody>
+      </p:sp>
+      <p:sp>
+        <p:nvSpPr>
+          <p:cNvPr id="98" name="Text 10"/>
+          <p:cNvSpPr/>
+          <p:nvPr/>
+        </p:nvSpPr>
+        <p:spPr>
+          <a:xfrm>
+            <a:off x="1047600" y="8724960"/>
+            <a:ext cx="2579400" cy="504360"/>
+          </a:xfrm>
+          <a:prstGeom prst="rect">
+            <a:avLst/>
+          </a:prstGeom>
+          <a:noFill/>
+          <a:ln w="0">
+            <a:noFill/>
+          </a:ln>
+        </p:spPr>
+        <p:style>
+          <a:lnRef idx="0"/>
+          <a:fillRef idx="0"/>
+          <a:effectRef idx="0"/>
+          <a:fontRef idx="minor"/>
+        </p:style>
+        <p:txBody>
+          <a:bodyPr lIns="25560" tIns="25560" rIns="25560" bIns="25560" anchor="t">
+            <a:normAutofit fontScale="85000" lnSpcReduction="9999"/>
+          </a:bodyPr>
+          <a:p>
+            <a:pPr defTabSz="914400">
+              <a:lnSpc>
+                <a:spcPct val="98000"/>
+              </a:lnSpc>
+              <a:tabLst>
+                <a:tab pos="0" algn="l"/>
+              </a:tabLst>
+            </a:pPr>
+            <a:r>
+              <a:rPr lang="en-US" sz="3750" b="0" u="none" spc="-37" strike="noStrike">
                 <a:solidFill>
                   <a:srgbClr val="1F2A24"/>
                 </a:solidFill>
@@ -13780,207 +14192,150 @@
                 <a:latin typeface="Georgia"/>
                 <a:ea typeface="Georgia"/>
               </a:rPr>
-              <a:t>We feed the bears, so the bears </a:t>
-            </a:r>
-            <a:r>
-              <a:rPr lang="en-US" sz="7800" b="0" i="1" u="none" spc="-79" strike="noStrike">
-                <a:solidFill>
-                  <a:srgbClr val="C4663A"/>
+              <a:t>↓ down</a:t>
+            </a:r>
+            <a:endParaRPr lang="en-US" sz="3750" b="0" u="none" strike="noStrike">
+              <a:solidFill>
+                <a:srgbClr val="000000"/>
+              </a:solidFill>
+              <a:effectLst/>
+              <a:uFillTx/>
+              <a:latin typeface="Arial"/>
+            </a:endParaRPr>
+          </a:p>
+        </p:txBody>
+      </p:sp>
+      <p:sp>
+        <p:nvSpPr>
+          <p:cNvPr id="99" name="Text 11"/>
+          <p:cNvSpPr/>
+          <p:nvPr/>
+        </p:nvSpPr>
+        <p:spPr>
+          <a:xfrm>
+            <a:off x="3837240" y="8458200"/>
+            <a:ext cx="2579400" cy="304560"/>
+          </a:xfrm>
+          <a:prstGeom prst="rect">
+            <a:avLst/>
+          </a:prstGeom>
+          <a:noFill/>
+          <a:ln w="0">
+            <a:noFill/>
+          </a:ln>
+        </p:spPr>
+        <p:style>
+          <a:lnRef idx="0"/>
+          <a:fillRef idx="0"/>
+          <a:effectRef idx="0"/>
+          <a:fontRef idx="minor"/>
+        </p:style>
+        <p:txBody>
+          <a:bodyPr lIns="25560" tIns="25560" rIns="25560" bIns="25560" anchor="t">
+            <a:normAutofit lnSpcReduction="9999"/>
+          </a:bodyPr>
+          <a:p>
+            <a:pPr defTabSz="914400">
+              <a:lnSpc>
+                <a:spcPct val="100000"/>
+              </a:lnSpc>
+              <a:tabLst>
+                <a:tab pos="0" algn="l"/>
+              </a:tabLst>
+            </a:pPr>
+            <a:r>
+              <a:rPr lang="en-US" sz="1800" b="0" u="none" spc="215" strike="noStrike">
+                <a:solidFill>
+                  <a:srgbClr val="4C554F"/>
+                </a:solidFill>
+                <a:effectLst/>
+                <a:uFillTx/>
+                <a:latin typeface="Courier New"/>
+                <a:ea typeface="Courier New"/>
+              </a:rPr>
+              <a:t>LANDSLIDE RISK</a:t>
+            </a:r>
+            <a:endParaRPr lang="en-US" sz="1800" b="0" u="none" strike="noStrike">
+              <a:solidFill>
+                <a:srgbClr val="000000"/>
+              </a:solidFill>
+              <a:effectLst/>
+              <a:uFillTx/>
+              <a:latin typeface="Arial"/>
+            </a:endParaRPr>
+          </a:p>
+        </p:txBody>
+      </p:sp>
+      <p:sp>
+        <p:nvSpPr>
+          <p:cNvPr id="100" name="Text 12"/>
+          <p:cNvSpPr/>
+          <p:nvPr/>
+        </p:nvSpPr>
+        <p:spPr>
+          <a:xfrm>
+            <a:off x="3837240" y="8724960"/>
+            <a:ext cx="2579400" cy="504360"/>
+          </a:xfrm>
+          <a:prstGeom prst="rect">
+            <a:avLst/>
+          </a:prstGeom>
+          <a:noFill/>
+          <a:ln w="0">
+            <a:noFill/>
+          </a:ln>
+        </p:spPr>
+        <p:style>
+          <a:lnRef idx="0"/>
+          <a:fillRef idx="0"/>
+          <a:effectRef idx="0"/>
+          <a:fontRef idx="minor"/>
+        </p:style>
+        <p:txBody>
+          <a:bodyPr lIns="25560" tIns="25560" rIns="25560" bIns="25560" anchor="t">
+            <a:normAutofit fontScale="85000" lnSpcReduction="9999"/>
+          </a:bodyPr>
+          <a:p>
+            <a:pPr defTabSz="914400">
+              <a:lnSpc>
+                <a:spcPct val="98000"/>
+              </a:lnSpc>
+              <a:tabLst>
+                <a:tab pos="0" algn="l"/>
+              </a:tabLst>
+            </a:pPr>
+            <a:r>
+              <a:rPr lang="en-US" sz="3750" b="0" u="none" spc="-37" strike="noStrike">
+                <a:solidFill>
+                  <a:srgbClr val="1F2A24"/>
                 </a:solidFill>
                 <a:effectLst/>
                 <a:uFillTx/>
                 <a:latin typeface="Georgia"/>
                 <a:ea typeface="Georgia"/>
               </a:rPr>
-              <a:t>stop visiting.</a:t>
-            </a:r>
-            <a:endParaRPr lang="en-US" sz="7800" b="0" u="none" strike="noStrike">
-              <a:solidFill>
-                <a:srgbClr val="000000"/>
-              </a:solidFill>
-              <a:effectLst/>
-              <a:uFillTx/>
-              <a:latin typeface="Arial"/>
-            </a:endParaRPr>
-          </a:p>
-        </p:txBody>
-      </p:sp>
-      <p:sp>
-        <p:nvSpPr>
-          <p:cNvPr id="94" name="Text 5"/>
-          <p:cNvSpPr/>
-          <p:nvPr/>
-        </p:nvSpPr>
-        <p:spPr>
-          <a:xfrm>
-            <a:off x="1047600" y="4855320"/>
-            <a:ext cx="8324640" cy="1584720"/>
-          </a:xfrm>
-          <a:prstGeom prst="rect">
-            <a:avLst/>
-          </a:prstGeom>
-          <a:noFill/>
-          <a:ln w="0">
-            <a:noFill/>
-          </a:ln>
-        </p:spPr>
-        <p:style>
-          <a:lnRef idx="0"/>
-          <a:fillRef idx="0"/>
-          <a:effectRef idx="0"/>
-          <a:fontRef idx="minor"/>
-        </p:style>
-        <p:txBody>
-          <a:bodyPr lIns="25560" tIns="25560" rIns="25560" bIns="25560" anchor="t">
-            <a:normAutofit fontScale="92500" lnSpcReduction="9999"/>
-          </a:bodyPr>
-          <a:p>
-            <a:pPr defTabSz="914400">
-              <a:lnSpc>
-                <a:spcPct val="145000"/>
-              </a:lnSpc>
-              <a:tabLst>
-                <a:tab pos="0" algn="l"/>
-              </a:tabLst>
-            </a:pPr>
-            <a:r>
-              <a:rPr lang="en-US" sz="2100" b="0" u="none" strike="noStrike">
-                <a:solidFill>
-                  <a:srgbClr val="1F2A24"/>
-                </a:solidFill>
-                <a:effectLst/>
-                <a:uFillTx/>
-                <a:latin typeface="Arial"/>
-                <a:ea typeface="Arial"/>
-              </a:rPr>
-              <a:t>Phased replacement of aged sugi (cedar) plantations with native broadleaf — oak, chestnut, konara. Done with local landowners and the Forestry Agency. The 25-year arc is the ecological clock, not the funding cycle.</a:t>
-            </a:r>
-            <a:endParaRPr lang="en-US" sz="2100" b="0" u="none" strike="noStrike">
-              <a:solidFill>
-                <a:srgbClr val="000000"/>
-              </a:solidFill>
-              <a:effectLst/>
-              <a:uFillTx/>
-              <a:latin typeface="Arial"/>
-            </a:endParaRPr>
-          </a:p>
-        </p:txBody>
-      </p:sp>
-      <p:sp>
-        <p:nvSpPr>
-          <p:cNvPr id="95" name="Text 6"/>
-          <p:cNvSpPr/>
-          <p:nvPr/>
-        </p:nvSpPr>
-        <p:spPr>
-          <a:xfrm>
-            <a:off x="1047600" y="6669000"/>
-            <a:ext cx="8324640" cy="1197720"/>
-          </a:xfrm>
-          <a:prstGeom prst="rect">
-            <a:avLst/>
-          </a:prstGeom>
-          <a:noFill/>
-          <a:ln w="0">
-            <a:noFill/>
-          </a:ln>
-        </p:spPr>
-        <p:style>
-          <a:lnRef idx="0"/>
-          <a:fillRef idx="0"/>
-          <a:effectRef idx="0"/>
-          <a:fontRef idx="minor"/>
-        </p:style>
-        <p:txBody>
-          <a:bodyPr lIns="25560" tIns="25560" rIns="25560" bIns="25560" anchor="t">
-            <a:normAutofit fontScale="92500" lnSpcReduction="9999"/>
-          </a:bodyPr>
-          <a:p>
-            <a:pPr defTabSz="914400">
-              <a:lnSpc>
-                <a:spcPct val="145000"/>
-              </a:lnSpc>
-              <a:tabLst>
-                <a:tab pos="0" algn="l"/>
-              </a:tabLst>
-            </a:pPr>
-            <a:r>
-              <a:rPr lang="en-US" sz="2100" b="0" u="none" strike="noStrike">
-                <a:solidFill>
-                  <a:srgbClr val="1F2A24"/>
-                </a:solidFill>
-                <a:effectLst/>
-                <a:uFillTx/>
-                <a:latin typeface="Arial"/>
-                <a:ea typeface="Arial"/>
-              </a:rPr>
-              <a:t>Broadleaf trees produce acorns and nuts that sustain deer, wild boar, and bear through winter. When the forest feeds them, they stay in the forest — and out of the village vegetable patch.</a:t>
-            </a:r>
-            <a:endParaRPr lang="en-US" sz="2100" b="0" u="none" strike="noStrike">
-              <a:solidFill>
-                <a:srgbClr val="000000"/>
-              </a:solidFill>
-              <a:effectLst/>
-              <a:uFillTx/>
-              <a:latin typeface="Arial"/>
-            </a:endParaRPr>
-          </a:p>
-        </p:txBody>
-      </p:sp>
-      <p:sp>
-        <p:nvSpPr>
-          <p:cNvPr id="96" name="Shape 7"/>
-          <p:cNvSpPr/>
-          <p:nvPr/>
-        </p:nvSpPr>
-        <p:spPr>
-          <a:xfrm>
-            <a:off x="1047600" y="8191080"/>
-            <a:ext cx="8082360" cy="9000"/>
-          </a:xfrm>
-          <a:prstGeom prst="rect">
-            <a:avLst/>
-          </a:prstGeom>
-          <a:solidFill>
-            <a:srgbClr val="1F2A24">
-              <a:alpha val="50000"/>
-            </a:srgbClr>
-          </a:solidFill>
-          <a:ln w="0">
-            <a:noFill/>
-          </a:ln>
-        </p:spPr>
-        <p:style>
-          <a:lnRef idx="0"/>
-          <a:fillRef idx="0"/>
-          <a:effectRef idx="0"/>
-          <a:fontRef idx="minor"/>
-        </p:style>
-        <p:txBody>
-          <a:bodyPr lIns="90000" tIns="-35640" rIns="90000" bIns="-35640" anchor="t">
-            <a:noAutofit/>
-          </a:bodyPr>
-          <a:p>
-            <a:endParaRPr lang="en-US" sz="1800" b="0" u="none" strike="noStrike">
-              <a:solidFill>
-                <a:srgbClr val="FFFFFF"/>
-              </a:solidFill>
-              <a:effectLst/>
-              <a:uFillTx/>
-              <a:latin typeface="Arial"/>
-            </a:endParaRPr>
-          </a:p>
-        </p:txBody>
-      </p:sp>
-      <p:sp>
-        <p:nvSpPr>
-          <p:cNvPr id="97" name="Text 8"/>
-          <p:cNvSpPr/>
-          <p:nvPr/>
-        </p:nvSpPr>
-        <p:spPr>
-          <a:xfrm>
-            <a:off x="1047600" y="8409960"/>
+              <a:t>↓ down</a:t>
+            </a:r>
+            <a:endParaRPr lang="en-US" sz="3750" b="0" u="none" strike="noStrike">
+              <a:solidFill>
+                <a:srgbClr val="000000"/>
+              </a:solidFill>
+              <a:effectLst/>
+              <a:uFillTx/>
+              <a:latin typeface="Arial"/>
+            </a:endParaRPr>
+          </a:p>
+        </p:txBody>
+      </p:sp>
+      <p:sp>
+        <p:nvSpPr>
+          <p:cNvPr id="101" name="Text 13"/>
+          <p:cNvSpPr/>
+          <p:nvPr/>
+        </p:nvSpPr>
+        <p:spPr>
+          <a:xfrm>
+            <a:off x="6626520" y="8458200"/>
             <a:ext cx="2579400" cy="304560"/>
           </a:xfrm>
           <a:prstGeom prst="rect">
@@ -14020,7 +14375,7 @@
                 <a:latin typeface="Courier New"/>
                 <a:ea typeface="Courier New"/>
               </a:rPr>
-              <a:t>POLLEN</a:t>
+              <a:t>NATIVE CANOPY</a:t>
             </a:r>
             <a:endParaRPr lang="en-US" sz="1800" b="0" u="none" strike="noStrike">
               <a:solidFill>
@@ -14035,13 +14390,13 @@
       </p:sp>
       <p:sp>
         <p:nvSpPr>
-          <p:cNvPr id="98" name="Text 9"/>
-          <p:cNvSpPr/>
-          <p:nvPr/>
-        </p:nvSpPr>
-        <p:spPr>
-          <a:xfrm>
-            <a:off x="1047600" y="8676720"/>
+          <p:cNvPr id="102" name="Text 14"/>
+          <p:cNvSpPr/>
+          <p:nvPr/>
+        </p:nvSpPr>
+        <p:spPr>
+          <a:xfrm>
+            <a:off x="6626520" y="8724960"/>
             <a:ext cx="2579400" cy="504360"/>
           </a:xfrm>
           <a:prstGeom prst="rect">
@@ -14081,7 +14436,7 @@
                 <a:latin typeface="Georgia"/>
                 <a:ea typeface="Georgia"/>
               </a:rPr>
-              <a:t>↓ down</a:t>
+              <a:t>↑ up</a:t>
             </a:r>
             <a:endParaRPr lang="en-US" sz="3750" b="0" u="none" strike="noStrike">
               <a:solidFill>
@@ -14096,258 +14451,14 @@
       </p:sp>
       <p:sp>
         <p:nvSpPr>
-          <p:cNvPr id="99" name="Text 10"/>
-          <p:cNvSpPr/>
-          <p:nvPr/>
-        </p:nvSpPr>
-        <p:spPr>
-          <a:xfrm>
-            <a:off x="3837240" y="8409960"/>
-            <a:ext cx="2579400" cy="304560"/>
-          </a:xfrm>
-          <a:prstGeom prst="rect">
-            <a:avLst/>
-          </a:prstGeom>
-          <a:noFill/>
-          <a:ln w="0">
-            <a:noFill/>
-          </a:ln>
-        </p:spPr>
-        <p:style>
-          <a:lnRef idx="0"/>
-          <a:fillRef idx="0"/>
-          <a:effectRef idx="0"/>
-          <a:fontRef idx="minor"/>
-        </p:style>
-        <p:txBody>
-          <a:bodyPr lIns="25560" tIns="25560" rIns="25560" bIns="25560" anchor="t">
-            <a:normAutofit lnSpcReduction="9999"/>
-          </a:bodyPr>
-          <a:p>
-            <a:pPr defTabSz="914400">
-              <a:lnSpc>
-                <a:spcPct val="100000"/>
-              </a:lnSpc>
-              <a:tabLst>
-                <a:tab pos="0" algn="l"/>
-              </a:tabLst>
-            </a:pPr>
-            <a:r>
-              <a:rPr lang="en-US" sz="1800" b="0" u="none" spc="215" strike="noStrike">
-                <a:solidFill>
-                  <a:srgbClr val="4C554F"/>
-                </a:solidFill>
-                <a:effectLst/>
-                <a:uFillTx/>
-                <a:latin typeface="Courier New"/>
-                <a:ea typeface="Courier New"/>
-              </a:rPr>
-              <a:t>LANDSLIDE RISK</a:t>
-            </a:r>
-            <a:endParaRPr lang="en-US" sz="1800" b="0" u="none" strike="noStrike">
-              <a:solidFill>
-                <a:srgbClr val="000000"/>
-              </a:solidFill>
-              <a:effectLst/>
-              <a:uFillTx/>
-              <a:latin typeface="Arial"/>
-            </a:endParaRPr>
-          </a:p>
-        </p:txBody>
-      </p:sp>
-      <p:sp>
-        <p:nvSpPr>
-          <p:cNvPr id="100" name="Text 11"/>
-          <p:cNvSpPr/>
-          <p:nvPr/>
-        </p:nvSpPr>
-        <p:spPr>
-          <a:xfrm>
-            <a:off x="3837240" y="8676720"/>
-            <a:ext cx="2579400" cy="504360"/>
-          </a:xfrm>
-          <a:prstGeom prst="rect">
-            <a:avLst/>
-          </a:prstGeom>
-          <a:noFill/>
-          <a:ln w="0">
-            <a:noFill/>
-          </a:ln>
-        </p:spPr>
-        <p:style>
-          <a:lnRef idx="0"/>
-          <a:fillRef idx="0"/>
-          <a:effectRef idx="0"/>
-          <a:fontRef idx="minor"/>
-        </p:style>
-        <p:txBody>
-          <a:bodyPr lIns="25560" tIns="25560" rIns="25560" bIns="25560" anchor="t">
-            <a:normAutofit fontScale="85000" lnSpcReduction="9999"/>
-          </a:bodyPr>
-          <a:p>
-            <a:pPr defTabSz="914400">
-              <a:lnSpc>
-                <a:spcPct val="98000"/>
-              </a:lnSpc>
-              <a:tabLst>
-                <a:tab pos="0" algn="l"/>
-              </a:tabLst>
-            </a:pPr>
-            <a:r>
-              <a:rPr lang="en-US" sz="3750" b="0" u="none" spc="-37" strike="noStrike">
-                <a:solidFill>
-                  <a:srgbClr val="1F2A24"/>
-                </a:solidFill>
-                <a:effectLst/>
-                <a:uFillTx/>
-                <a:latin typeface="Georgia"/>
-                <a:ea typeface="Georgia"/>
-              </a:rPr>
-              <a:t>↓ down</a:t>
-            </a:r>
-            <a:endParaRPr lang="en-US" sz="3750" b="0" u="none" strike="noStrike">
-              <a:solidFill>
-                <a:srgbClr val="000000"/>
-              </a:solidFill>
-              <a:effectLst/>
-              <a:uFillTx/>
-              <a:latin typeface="Arial"/>
-            </a:endParaRPr>
-          </a:p>
-        </p:txBody>
-      </p:sp>
-      <p:sp>
-        <p:nvSpPr>
-          <p:cNvPr id="101" name="Text 12"/>
-          <p:cNvSpPr/>
-          <p:nvPr/>
-        </p:nvSpPr>
-        <p:spPr>
-          <a:xfrm>
-            <a:off x="6626520" y="8409960"/>
-            <a:ext cx="2579400" cy="304560"/>
-          </a:xfrm>
-          <a:prstGeom prst="rect">
-            <a:avLst/>
-          </a:prstGeom>
-          <a:noFill/>
-          <a:ln w="0">
-            <a:noFill/>
-          </a:ln>
-        </p:spPr>
-        <p:style>
-          <a:lnRef idx="0"/>
-          <a:fillRef idx="0"/>
-          <a:effectRef idx="0"/>
-          <a:fontRef idx="minor"/>
-        </p:style>
-        <p:txBody>
-          <a:bodyPr lIns="25560" tIns="25560" rIns="25560" bIns="25560" anchor="t">
-            <a:normAutofit lnSpcReduction="9999"/>
-          </a:bodyPr>
-          <a:p>
-            <a:pPr defTabSz="914400">
-              <a:lnSpc>
-                <a:spcPct val="100000"/>
-              </a:lnSpc>
-              <a:tabLst>
-                <a:tab pos="0" algn="l"/>
-              </a:tabLst>
-            </a:pPr>
-            <a:r>
-              <a:rPr lang="en-US" sz="1800" b="0" u="none" spc="215" strike="noStrike">
-                <a:solidFill>
-                  <a:srgbClr val="4C554F"/>
-                </a:solidFill>
-                <a:effectLst/>
-                <a:uFillTx/>
-                <a:latin typeface="Courier New"/>
-                <a:ea typeface="Courier New"/>
-              </a:rPr>
-              <a:t>NATIVE CANOPY</a:t>
-            </a:r>
-            <a:endParaRPr lang="en-US" sz="1800" b="0" u="none" strike="noStrike">
-              <a:solidFill>
-                <a:srgbClr val="000000"/>
-              </a:solidFill>
-              <a:effectLst/>
-              <a:uFillTx/>
-              <a:latin typeface="Arial"/>
-            </a:endParaRPr>
-          </a:p>
-        </p:txBody>
-      </p:sp>
-      <p:sp>
-        <p:nvSpPr>
-          <p:cNvPr id="102" name="Text 13"/>
-          <p:cNvSpPr/>
-          <p:nvPr/>
-        </p:nvSpPr>
-        <p:spPr>
-          <a:xfrm>
-            <a:off x="6626520" y="8676720"/>
-            <a:ext cx="2579400" cy="504360"/>
-          </a:xfrm>
-          <a:prstGeom prst="rect">
-            <a:avLst/>
-          </a:prstGeom>
-          <a:noFill/>
-          <a:ln w="0">
-            <a:noFill/>
-          </a:ln>
-        </p:spPr>
-        <p:style>
-          <a:lnRef idx="0"/>
-          <a:fillRef idx="0"/>
-          <a:effectRef idx="0"/>
-          <a:fontRef idx="minor"/>
-        </p:style>
-        <p:txBody>
-          <a:bodyPr lIns="25560" tIns="25560" rIns="25560" bIns="25560" anchor="t">
-            <a:normAutofit fontScale="85000" lnSpcReduction="9999"/>
-          </a:bodyPr>
-          <a:p>
-            <a:pPr defTabSz="914400">
-              <a:lnSpc>
-                <a:spcPct val="98000"/>
-              </a:lnSpc>
-              <a:tabLst>
-                <a:tab pos="0" algn="l"/>
-              </a:tabLst>
-            </a:pPr>
-            <a:r>
-              <a:rPr lang="en-US" sz="3750" b="0" u="none" spc="-37" strike="noStrike">
-                <a:solidFill>
-                  <a:srgbClr val="1F2A24"/>
-                </a:solidFill>
-                <a:effectLst/>
-                <a:uFillTx/>
-                <a:latin typeface="Georgia"/>
-                <a:ea typeface="Georgia"/>
-              </a:rPr>
-              <a:t>↑ up</a:t>
-            </a:r>
-            <a:endParaRPr lang="en-US" sz="3750" b="0" u="none" strike="noStrike">
-              <a:solidFill>
-                <a:srgbClr val="000000"/>
-              </a:solidFill>
-              <a:effectLst/>
-              <a:uFillTx/>
-              <a:latin typeface="Arial"/>
-            </a:endParaRPr>
-          </a:p>
-        </p:txBody>
-      </p:sp>
-      <p:sp>
-        <p:nvSpPr>
-          <p:cNvPr id="103" name="Shape 14"/>
+          <p:cNvPr id="103" name="Shape 15"/>
           <p:cNvSpPr/>
           <p:nvPr/>
         </p:nvSpPr>
         <p:spPr>
           <a:xfrm>
             <a:off x="9892440" y="1695600"/>
-            <a:ext cx="7347600" cy="3666600"/>
+            <a:ext cx="7347600" cy="3333600"/>
           </a:xfrm>
           <a:prstGeom prst="rect">
             <a:avLst/>
@@ -14386,7 +14497,7 @@
       </p:sp>
       <p:sp>
         <p:nvSpPr>
-          <p:cNvPr id="104" name="Text 15"/>
+          <p:cNvPr id="104" name="Text 16"/>
           <p:cNvSpPr/>
           <p:nvPr/>
         </p:nvSpPr>
@@ -14483,7 +14594,7 @@
       </p:pic>
       <p:sp>
         <p:nvSpPr>
-          <p:cNvPr id="106" name="Text 16"/>
+          <p:cNvPr id="106" name="Text 17"/>
           <p:cNvSpPr/>
           <p:nvPr/>
         </p:nvSpPr>
@@ -14544,14 +14655,14 @@
       </p:sp>
       <p:sp>
         <p:nvSpPr>
-          <p:cNvPr id="107" name="Shape 17"/>
-          <p:cNvSpPr/>
-          <p:nvPr/>
-        </p:nvSpPr>
-        <p:spPr>
-          <a:xfrm>
-            <a:off x="9892440" y="5591160"/>
-            <a:ext cx="7347600" cy="3666600"/>
+          <p:cNvPr id="107" name="Shape 18"/>
+          <p:cNvSpPr/>
+          <p:nvPr/>
+        </p:nvSpPr>
+        <p:spPr>
+          <a:xfrm>
+            <a:off x="9892440" y="5729760"/>
+            <a:ext cx="7347600" cy="3185640"/>
           </a:xfrm>
           <a:prstGeom prst="rect">
             <a:avLst/>
@@ -14590,13 +14701,13 @@
       </p:sp>
       <p:sp>
         <p:nvSpPr>
-          <p:cNvPr id="108" name="Text 18"/>
-          <p:cNvSpPr/>
-          <p:nvPr/>
-        </p:nvSpPr>
-        <p:spPr>
-          <a:xfrm>
-            <a:off x="10168560" y="5867280"/>
+          <p:cNvPr id="108" name="Text 19"/>
+          <p:cNvSpPr/>
+          <p:nvPr/>
+        </p:nvSpPr>
+        <p:spPr>
+          <a:xfrm>
+            <a:off x="10168560" y="6005880"/>
             <a:ext cx="6999120" cy="380520"/>
           </a:xfrm>
           <a:prstGeom prst="rect">
@@ -14673,7 +14784,7 @@
         </p:blipFill>
         <p:spPr>
           <a:xfrm>
-            <a:off x="10168560" y="6381720"/>
+            <a:off x="10168560" y="6520320"/>
             <a:ext cx="6795000" cy="1523520"/>
           </a:xfrm>
           <a:prstGeom prst="rect">
@@ -14687,13 +14798,13 @@
       </p:pic>
       <p:sp>
         <p:nvSpPr>
-          <p:cNvPr id="110" name="Text 19"/>
-          <p:cNvSpPr/>
-          <p:nvPr/>
-        </p:nvSpPr>
-        <p:spPr>
-          <a:xfrm>
-            <a:off x="10168560" y="7943760"/>
+          <p:cNvPr id="110" name="Text 20"/>
+          <p:cNvSpPr/>
+          <p:nvPr/>
+        </p:nvSpPr>
+        <p:spPr>
+          <a:xfrm>
+            <a:off x="10168560" y="8082360"/>
             <a:ext cx="6999120" cy="369360"/>
           </a:xfrm>
           <a:prstGeom prst="rect">
@@ -14748,13 +14859,13 @@
       </p:sp>
       <p:sp>
         <p:nvSpPr>
-          <p:cNvPr id="111" name="Text 20"/>
-          <p:cNvSpPr/>
-          <p:nvPr/>
-        </p:nvSpPr>
-        <p:spPr>
-          <a:xfrm>
-            <a:off x="1047600" y="9258480"/>
+          <p:cNvPr id="111" name="Text 21"/>
+          <p:cNvSpPr/>
+          <p:nvPr/>
+        </p:nvSpPr>
+        <p:spPr>
+          <a:xfrm>
+            <a:off x="1047600" y="9535320"/>
             <a:ext cx="1154520" cy="304560"/>
           </a:xfrm>
           <a:prstGeom prst="rect">
@@ -14809,13 +14920,13 @@
       </p:sp>
       <p:sp>
         <p:nvSpPr>
-          <p:cNvPr id="112" name="Text 21"/>
-          <p:cNvSpPr/>
-          <p:nvPr/>
-        </p:nvSpPr>
-        <p:spPr>
-          <a:xfrm>
-            <a:off x="9323280" y="9258480"/>
+          <p:cNvPr id="112" name="Text 22"/>
+          <p:cNvSpPr/>
+          <p:nvPr/>
+        </p:nvSpPr>
+        <p:spPr>
+          <a:xfrm>
+            <a:off x="9323280" y="9535320"/>
             <a:ext cx="8154000" cy="304560"/>
           </a:xfrm>
           <a:prstGeom prst="rect">
@@ -14956,7 +15067,7 @@
         </p:nvSpPr>
         <p:spPr>
           <a:xfrm>
-            <a:off x="1119600" y="798120"/>
+            <a:off x="1047600" y="762120"/>
             <a:ext cx="533160" cy="495000"/>
           </a:xfrm>
           <a:prstGeom prst="rect">
@@ -15191,7 +15302,7 @@
                 <a:latin typeface="Georgia"/>
                 <a:ea typeface="Georgia"/>
               </a:rPr>
-              <a:t>Local sun. Local chargers. </a:t>
+              <a:t>The forest powers the village. </a:t>
             </a:r>
             <a:r>
               <a:rPr lang="en-US" sz="7200" b="0" i="1" u="none" spc="-71" strike="noStrike">
@@ -15237,7 +15348,7 @@
         <p:spPr>
           <a:xfrm>
             <a:off x="1047600" y="3935520"/>
-            <a:ext cx="12217320" cy="1584720"/>
+            <a:ext cx="12217320" cy="1971360"/>
           </a:xfrm>
           <a:prstGeom prst="rect">
             <a:avLst/>
@@ -15276,43 +15387,7 @@
                 <a:latin typeface="Arial"/>
                 <a:ea typeface="Arial"/>
               </a:rPr>
-              <a:t>Privately-owned village solar feeds a shared bus, with a community battery for the dark hours </a:t>
-            </a:r>
-            <a:r>
-              <a:rPr lang="en-US" sz="2100" b="0" u="none" strike="noStrike">
-                <a:solidFill>
-                  <a:srgbClr val="1F2A24"/>
-                </a:solidFill>
-                <a:effectLst/>
-                <a:uFillTx/>
-                <a:latin typeface="Arial"/>
-                <a:ea typeface="Arial"/>
-              </a:rPr>
-              <a:t>and the grid as backup. EV chargers tie to local generation instead of waiting on grid extension. </a:t>
-            </a:r>
-            <a:r>
-              <a:rPr lang="en-US" sz="2100" b="0" u="none" strike="noStrike">
-                <a:solidFill>
-                  <a:srgbClr val="1F2A24"/>
-                </a:solidFill>
-                <a:effectLst/>
-                <a:uFillTx/>
-                <a:latin typeface="Arial"/>
-                <a:ea typeface="Arial"/>
-              </a:rPr>
-              <a:t>On-site generation keeps the school, the clinic, and emergency facilities running through </a:t>
-            </a:r>
-            <a:r>
-              <a:rPr lang="en-US" sz="2100" b="0" u="none" strike="noStrike">
-                <a:solidFill>
-                  <a:srgbClr val="1F2A24"/>
-                </a:solidFill>
-                <a:effectLst/>
-                <a:uFillTx/>
-                <a:latin typeface="Arial"/>
-                <a:ea typeface="Arial"/>
-              </a:rPr>
-              <a:t>blackouts — and aging rural distribution lines make those a growing risk.</a:t>
+              <a:t>The sugi we remove during forest restoration is the primary fuel for a small village biomass plant — enough to run the data center and the EV chargers. Local solar tops it up, a community battery rides through the dark hours, and the grid is backup only. On-site generation keeps the school, the clinic, and emergency facilities running through blackouts — aging rural distribution lines make those a growing risk.</a:t>
             </a:r>
             <a:endParaRPr lang="en-US" sz="2100" b="0" u="none" strike="noStrike">
               <a:solidFill>
@@ -15333,8 +15408,8 @@
         </p:nvSpPr>
         <p:spPr>
           <a:xfrm>
-            <a:off x="1047600" y="6053760"/>
-            <a:ext cx="16192080" cy="3204000"/>
+            <a:off x="952920" y="5640840"/>
+            <a:ext cx="16192080" cy="2817360"/>
           </a:xfrm>
           <a:prstGeom prst="rect">
             <a:avLst/>
@@ -15383,8 +15458,8 @@
         </p:blipFill>
         <p:spPr>
           <a:xfrm>
-            <a:off x="1400040" y="6406200"/>
-            <a:ext cx="15487200" cy="2499480"/>
+            <a:off x="1305360" y="5993280"/>
+            <a:ext cx="15487200" cy="2112480"/>
           </a:xfrm>
           <a:prstGeom prst="rect">
             <a:avLst/>
@@ -15464,8 +15539,8 @@
         </p:nvSpPr>
         <p:spPr>
           <a:xfrm>
-            <a:off x="9323280" y="9258480"/>
-            <a:ext cx="8154000" cy="304560"/>
+            <a:off x="8546040" y="9258480"/>
+            <a:ext cx="8954640" cy="304560"/>
           </a:xfrm>
           <a:prstGeom prst="rect">
             <a:avLst/>
@@ -15504,7 +15579,7 @@
                 <a:latin typeface="Courier New"/>
                 <a:ea typeface="Courier New"/>
               </a:rPr>
-              <a:t>SOLAR · STORAGE · EV CHARGING · BLACKOUT RESILIENCE</a:t>
+              <a:t>SUGI BIOMASS · SOLAR · EV CHARGING · BLACKOUT RESILIENCE</a:t>
             </a:r>
             <a:endParaRPr lang="en-US" sz="1800" b="0" u="none" strike="noStrike">
               <a:solidFill>
@@ -15605,7 +15680,7 @@
         </p:nvSpPr>
         <p:spPr>
           <a:xfrm>
-            <a:off x="1119600" y="798120"/>
+            <a:off x="1047600" y="762120"/>
             <a:ext cx="533160" cy="495000"/>
           </a:xfrm>
           <a:prstGeom prst="rect">
@@ -15873,7 +15948,7 @@
         </p:nvSpPr>
         <p:spPr>
           <a:xfrm>
-            <a:off x="1047600" y="4548240"/>
+            <a:off x="1047600" y="4114800"/>
             <a:ext cx="7946280" cy="1197720"/>
           </a:xfrm>
           <a:prstGeom prst="rect">
@@ -15934,7 +16009,7 @@
         </p:nvSpPr>
         <p:spPr>
           <a:xfrm>
-            <a:off x="1047600" y="5974920"/>
+            <a:off x="1047600" y="5541480"/>
             <a:ext cx="7946280" cy="1971360"/>
           </a:xfrm>
           <a:prstGeom prst="rect">
@@ -16741,7 +16816,7 @@
         </p:nvSpPr>
         <p:spPr>
           <a:xfrm>
-            <a:off x="1119600" y="798120"/>
+            <a:off x="1047600" y="762120"/>
             <a:ext cx="533160" cy="495000"/>
           </a:xfrm>
           <a:prstGeom prst="rect">
@@ -16968,19 +17043,7 @@
                 <a:latin typeface="Georgia"/>
                 <a:ea typeface="Georgia"/>
               </a:rPr>
-              <a:t>The win doesn't depend on the data </a:t>
-            </a:r>
-            <a:r>
-              <a:rPr lang="en-US" sz="9000" b="0" u="none" spc="-91" strike="noStrike">
-                <a:solidFill>
-                  <a:srgbClr val="F3ECE0"/>
-                </a:solidFill>
-                <a:effectLst/>
-                <a:uFillTx/>
-                <a:latin typeface="Georgia"/>
-                <a:ea typeface="Georgia"/>
-              </a:rPr>
-              <a:t>center being a </a:t>
+              <a:t>The win doesn't depend on the data center being a </a:t>
             </a:r>
             <a:r>
               <a:rPr lang="en-US" sz="9000" b="0" i="1" u="none" spc="-91" strike="noStrike">
@@ -18143,7 +18206,7 @@
         </p:nvSpPr>
         <p:spPr>
           <a:xfrm>
-            <a:off x="1119600" y="798120"/>
+            <a:off x="1047600" y="762120"/>
             <a:ext cx="533160" cy="495000"/>
           </a:xfrm>
           <a:prstGeom prst="rect">
@@ -18430,7 +18493,7 @@
               </a:tabLst>
             </a:pPr>
             <a:r>
-              <a:rPr lang="en-US" sz="7200" b="0" u="none" spc="-79" strike="noStrike">
+              <a:rPr lang="en-US" sz="7800" b="0" u="none" spc="-79" strike="noStrike">
                 <a:solidFill>
                   <a:srgbClr val="1F2A24"/>
                 </a:solidFill>
@@ -18442,7 +18505,7 @@
               <a:t>Quiet on purpose. </a:t>
             </a:r>
             <a:r>
-              <a:rPr lang="en-US" sz="7200" b="0" i="1" u="none" spc="-79" strike="noStrike">
+              <a:rPr lang="en-US" sz="7800" b="0" i="1" u="none" spc="-79" strike="noStrike">
                 <a:solidFill>
                   <a:srgbClr val="C4663A"/>
                 </a:solidFill>
@@ -18451,22 +18514,238 @@
                 <a:latin typeface="Georgia"/>
                 <a:ea typeface="Georgia"/>
               </a:rPr>
-              <a:t>No </a:t>
-            </a:r>
-            <a:r>
-              <a:rPr lang="en-US" sz="7200" b="0" i="1" u="none" spc="-79" strike="noStrike">
-                <a:solidFill>
-                  <a:srgbClr val="C4663A"/>
+              <a:t>No press, </a:t>
+            </a:r>
+            <a:r>
+              <a:rPr lang="en-US" sz="7800" b="0" u="none" spc="-79" strike="noStrike">
+                <a:solidFill>
+                  <a:srgbClr val="1F2A24"/>
                 </a:solidFill>
                 <a:effectLst/>
                 <a:uFillTx/>
                 <a:latin typeface="Georgia"/>
                 <a:ea typeface="Georgia"/>
               </a:rPr>
-              <a:t>press, </a:t>
-            </a:r>
-            <a:r>
-              <a:rPr lang="en-US" sz="7200" b="0" u="none" spc="-79" strike="noStrike">
+              <a:t>no website launch, no founder hoodies.</a:t>
+            </a:r>
+            <a:endParaRPr lang="en-US" sz="7800" b="0" u="none" strike="noStrike">
+              <a:solidFill>
+                <a:srgbClr val="000000"/>
+              </a:solidFill>
+              <a:effectLst/>
+              <a:uFillTx/>
+              <a:latin typeface="Arial"/>
+            </a:endParaRPr>
+          </a:p>
+        </p:txBody>
+      </p:sp>
+      <p:sp>
+        <p:nvSpPr>
+          <p:cNvPr id="165" name="Text 6"/>
+          <p:cNvSpPr/>
+          <p:nvPr/>
+        </p:nvSpPr>
+        <p:spPr>
+          <a:xfrm>
+            <a:off x="1047600" y="7362720"/>
+            <a:ext cx="8246520" cy="1197720"/>
+          </a:xfrm>
+          <a:prstGeom prst="rect">
+            <a:avLst/>
+          </a:prstGeom>
+          <a:noFill/>
+          <a:ln w="0">
+            <a:noFill/>
+          </a:ln>
+        </p:spPr>
+        <p:style>
+          <a:lnRef idx="0"/>
+          <a:fillRef idx="0"/>
+          <a:effectRef idx="0"/>
+          <a:fontRef idx="minor"/>
+        </p:style>
+        <p:txBody>
+          <a:bodyPr lIns="25560" tIns="25560" rIns="25560" bIns="25560" anchor="t">
+            <a:normAutofit fontScale="92500" lnSpcReduction="9999"/>
+          </a:bodyPr>
+          <a:p>
+            <a:pPr defTabSz="914400">
+              <a:lnSpc>
+                <a:spcPct val="145000"/>
+              </a:lnSpc>
+              <a:tabLst>
+                <a:tab pos="0" algn="l"/>
+              </a:tabLst>
+            </a:pPr>
+            <a:r>
+              <a:rPr lang="en-US" sz="2100" b="0" u="none" strike="noStrike">
+                <a:solidFill>
+                  <a:srgbClr val="1F2A24"/>
+                </a:solidFill>
+                <a:effectLst/>
+                <a:uFillTx/>
+                <a:latin typeface="Arial"/>
+                <a:ea typeface="Arial"/>
+              </a:rPr>
+              <a:t>Phase 0 is local trust-building, founding-team formation, and clean drafting of the charter. Self-funded, ¥0–0.5M. The work that matters right now is meetings, not announcements.</a:t>
+            </a:r>
+            <a:endParaRPr lang="en-US" sz="2100" b="0" u="none" strike="noStrike">
+              <a:solidFill>
+                <a:srgbClr val="000000"/>
+              </a:solidFill>
+              <a:effectLst/>
+              <a:uFillTx/>
+              <a:latin typeface="Arial"/>
+            </a:endParaRPr>
+          </a:p>
+        </p:txBody>
+      </p:sp>
+      <p:sp>
+        <p:nvSpPr>
+          <p:cNvPr id="166" name="Shape 7"/>
+          <p:cNvSpPr/>
+          <p:nvPr/>
+        </p:nvSpPr>
+        <p:spPr>
+          <a:xfrm>
+            <a:off x="1047600" y="8865720"/>
+            <a:ext cx="8082360" cy="9000"/>
+          </a:xfrm>
+          <a:prstGeom prst="rect">
+            <a:avLst/>
+          </a:prstGeom>
+          <a:solidFill>
+            <a:srgbClr val="1F2A24">
+              <a:alpha val="50000"/>
+            </a:srgbClr>
+          </a:solidFill>
+          <a:ln w="0">
+            <a:noFill/>
+          </a:ln>
+        </p:spPr>
+        <p:style>
+          <a:lnRef idx="0"/>
+          <a:fillRef idx="0"/>
+          <a:effectRef idx="0"/>
+          <a:fontRef idx="minor"/>
+        </p:style>
+        <p:txBody>
+          <a:bodyPr lIns="90000" tIns="-35640" rIns="90000" bIns="-35640" anchor="t">
+            <a:noAutofit/>
+          </a:bodyPr>
+          <a:p>
+            <a:endParaRPr lang="en-US" sz="1800" b="0" u="none" strike="noStrike">
+              <a:solidFill>
+                <a:srgbClr val="FFFFFF"/>
+              </a:solidFill>
+              <a:effectLst/>
+              <a:uFillTx/>
+              <a:latin typeface="Arial"/>
+            </a:endParaRPr>
+          </a:p>
+        </p:txBody>
+      </p:sp>
+      <p:sp>
+        <p:nvSpPr>
+          <p:cNvPr id="167" name="Text 8"/>
+          <p:cNvSpPr/>
+          <p:nvPr/>
+        </p:nvSpPr>
+        <p:spPr>
+          <a:xfrm>
+            <a:off x="1047600" y="9084960"/>
+            <a:ext cx="8324640" cy="304560"/>
+          </a:xfrm>
+          <a:prstGeom prst="rect">
+            <a:avLst/>
+          </a:prstGeom>
+          <a:noFill/>
+          <a:ln w="0">
+            <a:noFill/>
+          </a:ln>
+        </p:spPr>
+        <p:style>
+          <a:lnRef idx="0"/>
+          <a:fillRef idx="0"/>
+          <a:effectRef idx="0"/>
+          <a:fontRef idx="minor"/>
+        </p:style>
+        <p:txBody>
+          <a:bodyPr lIns="25560" tIns="25560" rIns="25560" bIns="25560" anchor="t">
+            <a:normAutofit lnSpcReduction="9999"/>
+          </a:bodyPr>
+          <a:p>
+            <a:pPr defTabSz="914400">
+              <a:lnSpc>
+                <a:spcPct val="100000"/>
+              </a:lnSpc>
+              <a:tabLst>
+                <a:tab pos="0" algn="l"/>
+              </a:tabLst>
+            </a:pPr>
+            <a:r>
+              <a:rPr lang="en-US" sz="1800" b="0" u="none" spc="215" strike="noStrike">
+                <a:solidFill>
+                  <a:srgbClr val="4C554F"/>
+                </a:solidFill>
+                <a:effectLst/>
+                <a:uFillTx/>
+                <a:latin typeface="Courier New"/>
+                <a:ea typeface="Courier New"/>
+              </a:rPr>
+              <a:t>ADVISORY COMMITMENTS</a:t>
+            </a:r>
+            <a:endParaRPr lang="en-US" sz="1800" b="0" u="none" strike="noStrike">
+              <a:solidFill>
+                <a:srgbClr val="000000"/>
+              </a:solidFill>
+              <a:effectLst/>
+              <a:uFillTx/>
+              <a:latin typeface="Arial"/>
+            </a:endParaRPr>
+          </a:p>
+        </p:txBody>
+      </p:sp>
+      <p:sp>
+        <p:nvSpPr>
+          <p:cNvPr id="168" name="Text 9"/>
+          <p:cNvSpPr/>
+          <p:nvPr/>
+        </p:nvSpPr>
+        <p:spPr>
+          <a:xfrm>
+            <a:off x="1047600" y="9523080"/>
+            <a:ext cx="3336840" cy="533160"/>
+          </a:xfrm>
+          <a:prstGeom prst="rect">
+            <a:avLst/>
+          </a:prstGeom>
+          <a:noFill/>
+          <a:ln w="0">
+            <a:noFill/>
+          </a:ln>
+        </p:spPr>
+        <p:style>
+          <a:lnRef idx="0"/>
+          <a:fillRef idx="0"/>
+          <a:effectRef idx="0"/>
+          <a:fontRef idx="minor"/>
+        </p:style>
+        <p:txBody>
+          <a:bodyPr lIns="25560" tIns="25560" rIns="25560" bIns="25560" anchor="t">
+            <a:normAutofit fontScale="85000" lnSpcReduction="9999"/>
+          </a:bodyPr>
+          <a:p>
+            <a:pPr defTabSz="914400">
+              <a:lnSpc>
+                <a:spcPct val="100000"/>
+              </a:lnSpc>
+              <a:tabLst>
+                <a:tab pos="0" algn="l"/>
+              </a:tabLst>
+            </a:pPr>
+            <a:r>
+              <a:rPr lang="en-US" sz="3900" b="0" u="none" spc="-40" strike="noStrike">
                 <a:solidFill>
                   <a:srgbClr val="1F2A24"/>
                 </a:solidFill>
@@ -18475,10 +18754,120 @@
                 <a:latin typeface="Georgia"/>
                 <a:ea typeface="Georgia"/>
               </a:rPr>
-              <a:t>no website </a:t>
-            </a:r>
-            <a:r>
-              <a:rPr lang="en-US" sz="7200" b="0" u="none" spc="-79" strike="noStrike">
+              <a:t>Joi Ito</a:t>
+            </a:r>
+            <a:endParaRPr lang="en-US" sz="3900" b="0" u="none" strike="noStrike">
+              <a:solidFill>
+                <a:srgbClr val="000000"/>
+              </a:solidFill>
+              <a:effectLst/>
+              <a:uFillTx/>
+              <a:latin typeface="Arial"/>
+            </a:endParaRPr>
+          </a:p>
+        </p:txBody>
+      </p:sp>
+      <p:sp>
+        <p:nvSpPr>
+          <p:cNvPr id="169" name="Text 10"/>
+          <p:cNvSpPr/>
+          <p:nvPr/>
+        </p:nvSpPr>
+        <p:spPr>
+          <a:xfrm>
+            <a:off x="1047600" y="10018440"/>
+            <a:ext cx="3336840" cy="369360"/>
+          </a:xfrm>
+          <a:prstGeom prst="rect">
+            <a:avLst/>
+          </a:prstGeom>
+          <a:noFill/>
+          <a:ln w="0">
+            <a:noFill/>
+          </a:ln>
+        </p:spPr>
+        <p:style>
+          <a:lnRef idx="0"/>
+          <a:fillRef idx="0"/>
+          <a:effectRef idx="0"/>
+          <a:fontRef idx="minor"/>
+        </p:style>
+        <p:txBody>
+          <a:bodyPr lIns="25560" tIns="25560" rIns="25560" bIns="25560" anchor="t">
+            <a:normAutofit fontScale="85000" lnSpcReduction="9999"/>
+          </a:bodyPr>
+          <a:p>
+            <a:pPr defTabSz="914400">
+              <a:lnSpc>
+                <a:spcPct val="145000"/>
+              </a:lnSpc>
+              <a:tabLst>
+                <a:tab pos="0" algn="l"/>
+              </a:tabLst>
+            </a:pPr>
+            <a:r>
+              <a:rPr lang="en-US" sz="1800" b="0" u="none" strike="noStrike">
+                <a:solidFill>
+                  <a:srgbClr val="4C554F"/>
+                </a:solidFill>
+                <a:effectLst/>
+                <a:uFillTx/>
+                <a:latin typeface="Arial"/>
+                <a:ea typeface="Arial"/>
+              </a:rPr>
+              <a:t>Former Director, MIT Media Lab</a:t>
+            </a:r>
+            <a:endParaRPr lang="en-US" sz="1800" b="0" u="none" strike="noStrike">
+              <a:solidFill>
+                <a:srgbClr val="000000"/>
+              </a:solidFill>
+              <a:effectLst/>
+              <a:uFillTx/>
+              <a:latin typeface="Arial"/>
+            </a:endParaRPr>
+          </a:p>
+        </p:txBody>
+      </p:sp>
+      <p:sp>
+        <p:nvSpPr>
+          <p:cNvPr id="170" name="Text 11"/>
+          <p:cNvSpPr/>
+          <p:nvPr/>
+        </p:nvSpPr>
+        <p:spPr>
+          <a:xfrm>
+            <a:off x="4611600" y="9523080"/>
+            <a:ext cx="3808080" cy="533160"/>
+          </a:xfrm>
+          <a:prstGeom prst="rect">
+            <a:avLst/>
+          </a:prstGeom>
+          <a:noFill/>
+          <a:ln w="0">
+            <a:noFill/>
+          </a:ln>
+        </p:spPr>
+        <p:style>
+          <a:lnRef idx="0"/>
+          <a:fillRef idx="0"/>
+          <a:effectRef idx="0"/>
+          <a:fontRef idx="minor"/>
+        </p:style>
+        <p:txBody>
+          <a:bodyPr lIns="25560" tIns="25560" rIns="25560" bIns="25560" anchor="t">
+            <a:normAutofit fontScale="85000" lnSpcReduction="9999"/>
+          </a:bodyPr>
+          <a:p>
+            <a:pPr defTabSz="914400">
+              <a:lnSpc>
+                <a:spcPct val="100000"/>
+              </a:lnSpc>
+              <a:tabLst>
+                <a:tab pos="0" algn="l"/>
+              </a:tabLst>
+            </a:pPr>
+            <a:r>
+              <a:rPr lang="en-US" sz="3900" b="0" u="none" spc="-40" strike="noStrike">
                 <a:solidFill>
                   <a:srgbClr val="1F2A24"/>
                 </a:solidFill>
@@ -18487,41 +18876,29 @@
                 <a:latin typeface="Georgia"/>
                 <a:ea typeface="Georgia"/>
               </a:rPr>
-              <a:t>launch, no founder </a:t>
-            </a:r>
-            <a:r>
-              <a:rPr lang="en-US" sz="7200" b="0" u="none" spc="-79" strike="noStrike">
-                <a:solidFill>
-                  <a:srgbClr val="1F2A24"/>
-                </a:solidFill>
-                <a:effectLst/>
-                <a:uFillTx/>
-                <a:latin typeface="Georgia"/>
-                <a:ea typeface="Georgia"/>
-              </a:rPr>
-              <a:t>hoodies.</a:t>
-            </a:r>
-            <a:endParaRPr lang="en-US" sz="7200" b="0" u="none" strike="noStrike">
-              <a:solidFill>
-                <a:srgbClr val="000000"/>
-              </a:solidFill>
-              <a:effectLst/>
-              <a:uFillTx/>
-              <a:latin typeface="Arial"/>
-            </a:endParaRPr>
-          </a:p>
-        </p:txBody>
-      </p:sp>
-      <p:sp>
-        <p:nvSpPr>
-          <p:cNvPr id="165" name="Text 6"/>
-          <p:cNvSpPr/>
-          <p:nvPr/>
-        </p:nvSpPr>
-        <p:spPr>
-          <a:xfrm>
-            <a:off x="1125720" y="6629400"/>
-            <a:ext cx="8246520" cy="1197720"/>
+              <a:t>Ray Ozzie</a:t>
+            </a:r>
+            <a:endParaRPr lang="en-US" sz="3900" b="0" u="none" strike="noStrike">
+              <a:solidFill>
+                <a:srgbClr val="000000"/>
+              </a:solidFill>
+              <a:effectLst/>
+              <a:uFillTx/>
+              <a:latin typeface="Arial"/>
+            </a:endParaRPr>
+          </a:p>
+        </p:txBody>
+      </p:sp>
+      <p:sp>
+        <p:nvSpPr>
+          <p:cNvPr id="171" name="Text 12"/>
+          <p:cNvSpPr/>
+          <p:nvPr/>
+        </p:nvSpPr>
+        <p:spPr>
+          <a:xfrm>
+            <a:off x="4611600" y="10018440"/>
+            <a:ext cx="3808080" cy="369360"/>
           </a:xfrm>
           <a:prstGeom prst="rect">
             <a:avLst/>
@@ -18539,7 +18916,7 @@
         </p:style>
         <p:txBody>
           <a:bodyPr lIns="25560" tIns="25560" rIns="25560" bIns="25560" anchor="t">
-            <a:normAutofit fontScale="92500" lnSpcReduction="9999"/>
+            <a:normAutofit fontScale="85000" lnSpcReduction="9999"/>
           </a:bodyPr>
           <a:p>
             <a:pPr defTabSz="914400">
@@ -18551,77 +18928,16 @@
               </a:tabLst>
             </a:pPr>
             <a:r>
-              <a:rPr lang="en-US" sz="2100" b="0" u="none" strike="noStrike">
-                <a:solidFill>
-                  <a:srgbClr val="1F2A24"/>
+              <a:rPr lang="en-US" sz="1800" b="0" u="none" strike="noStrike">
+                <a:solidFill>
+                  <a:srgbClr val="4C554F"/>
                 </a:solidFill>
                 <a:effectLst/>
                 <a:uFillTx/>
                 <a:latin typeface="Arial"/>
                 <a:ea typeface="Arial"/>
               </a:rPr>
-              <a:t>Phase 0 is local trust-building, founding-team formation, and clean drafting of the charter. Self-funded, ¥0–0.5M. The work that matters right now is meetings, not announcements.</a:t>
-            </a:r>
-            <a:endParaRPr lang="en-US" sz="2100" b="0" u="none" strike="noStrike">
-              <a:solidFill>
-                <a:srgbClr val="000000"/>
-              </a:solidFill>
-              <a:effectLst/>
-              <a:uFillTx/>
-              <a:latin typeface="Arial"/>
-            </a:endParaRPr>
-          </a:p>
-        </p:txBody>
-      </p:sp>
-      <p:sp>
-        <p:nvSpPr>
-          <p:cNvPr id="166" name="Text 8"/>
-          <p:cNvSpPr/>
-          <p:nvPr/>
-        </p:nvSpPr>
-        <p:spPr>
-          <a:xfrm>
-            <a:off x="1143000" y="8001000"/>
-            <a:ext cx="8324640" cy="304560"/>
-          </a:xfrm>
-          <a:prstGeom prst="rect">
-            <a:avLst/>
-          </a:prstGeom>
-          <a:noFill/>
-          <a:ln w="0">
-            <a:noFill/>
-          </a:ln>
-        </p:spPr>
-        <p:style>
-          <a:lnRef idx="0"/>
-          <a:fillRef idx="0"/>
-          <a:effectRef idx="0"/>
-          <a:fontRef idx="minor"/>
-        </p:style>
-        <p:txBody>
-          <a:bodyPr lIns="25560" tIns="25560" rIns="25560" bIns="25560" anchor="t">
-            <a:normAutofit lnSpcReduction="9999"/>
-          </a:bodyPr>
-          <a:p>
-            <a:pPr defTabSz="914400">
-              <a:lnSpc>
-                <a:spcPct val="100000"/>
-              </a:lnSpc>
-              <a:tabLst>
-                <a:tab pos="0" algn="l"/>
-              </a:tabLst>
-            </a:pPr>
-            <a:r>
-              <a:rPr lang="en-US" sz="1800" b="0" u="none" spc="215" strike="noStrike">
-                <a:solidFill>
-                  <a:srgbClr val="4C554F"/>
-                </a:solidFill>
-                <a:effectLst/>
-                <a:uFillTx/>
-                <a:latin typeface="Courier New"/>
-                <a:ea typeface="Courier New"/>
-              </a:rPr>
-              <a:t>ADVISORY COMMITMENTS</a:t>
+              <a:t>Software pioneer · ex-Microsoft CSA</a:t>
             </a:r>
             <a:endParaRPr lang="en-US" sz="1800" b="0" u="none" strike="noStrike">
               <a:solidFill>
@@ -18636,251 +18952,7 @@
       </p:sp>
       <p:sp>
         <p:nvSpPr>
-          <p:cNvPr id="167" name="Text 9"/>
-          <p:cNvSpPr/>
-          <p:nvPr/>
-        </p:nvSpPr>
-        <p:spPr>
-          <a:xfrm>
-            <a:off x="1143000" y="8439120"/>
-            <a:ext cx="2379960" cy="533160"/>
-          </a:xfrm>
-          <a:prstGeom prst="rect">
-            <a:avLst/>
-          </a:prstGeom>
-          <a:noFill/>
-          <a:ln w="0">
-            <a:noFill/>
-          </a:ln>
-        </p:spPr>
-        <p:style>
-          <a:lnRef idx="0"/>
-          <a:fillRef idx="0"/>
-          <a:effectRef idx="0"/>
-          <a:fontRef idx="minor"/>
-        </p:style>
-        <p:txBody>
-          <a:bodyPr lIns="25560" tIns="25560" rIns="25560" bIns="25560" anchor="t">
-            <a:normAutofit fontScale="85000" lnSpcReduction="9999"/>
-          </a:bodyPr>
-          <a:p>
-            <a:pPr defTabSz="914400">
-              <a:lnSpc>
-                <a:spcPct val="100000"/>
-              </a:lnSpc>
-              <a:tabLst>
-                <a:tab pos="0" algn="l"/>
-              </a:tabLst>
-            </a:pPr>
-            <a:r>
-              <a:rPr lang="en-US" sz="3900" b="0" u="none" spc="-40" strike="noStrike">
-                <a:solidFill>
-                  <a:srgbClr val="1F2A24"/>
-                </a:solidFill>
-                <a:effectLst/>
-                <a:uFillTx/>
-                <a:latin typeface="Georgia"/>
-                <a:ea typeface="Georgia"/>
-              </a:rPr>
-              <a:t>Joi Ito</a:t>
-            </a:r>
-            <a:endParaRPr lang="en-US" sz="3900" b="0" u="none" strike="noStrike">
-              <a:solidFill>
-                <a:srgbClr val="000000"/>
-              </a:solidFill>
-              <a:effectLst/>
-              <a:uFillTx/>
-              <a:latin typeface="Arial"/>
-            </a:endParaRPr>
-          </a:p>
-        </p:txBody>
-      </p:sp>
-      <p:sp>
-        <p:nvSpPr>
-          <p:cNvPr id="168" name="Text 10"/>
-          <p:cNvSpPr/>
-          <p:nvPr/>
-        </p:nvSpPr>
-        <p:spPr>
-          <a:xfrm>
-            <a:off x="1143000" y="8934480"/>
-            <a:ext cx="2379960" cy="369360"/>
-          </a:xfrm>
-          <a:prstGeom prst="rect">
-            <a:avLst/>
-          </a:prstGeom>
-          <a:noFill/>
-          <a:ln w="0">
-            <a:noFill/>
-          </a:ln>
-        </p:spPr>
-        <p:style>
-          <a:lnRef idx="0"/>
-          <a:fillRef idx="0"/>
-          <a:effectRef idx="0"/>
-          <a:fontRef idx="minor"/>
-        </p:style>
-        <p:txBody>
-          <a:bodyPr lIns="25560" tIns="25560" rIns="25560" bIns="25560" anchor="t">
-            <a:normAutofit fontScale="62500" lnSpcReduction="19999"/>
-          </a:bodyPr>
-          <a:p>
-            <a:pPr defTabSz="914400">
-              <a:lnSpc>
-                <a:spcPct val="145000"/>
-              </a:lnSpc>
-              <a:tabLst>
-                <a:tab pos="0" algn="l"/>
-              </a:tabLst>
-            </a:pPr>
-            <a:r>
-              <a:rPr lang="en-US" sz="1800" b="0" u="none" strike="noStrike">
-                <a:solidFill>
-                  <a:srgbClr val="4C554F"/>
-                </a:solidFill>
-                <a:effectLst/>
-                <a:uFillTx/>
-                <a:latin typeface="Arial"/>
-                <a:ea typeface="Arial"/>
-              </a:rPr>
-              <a:t>Former Director, MIT Media Lab</a:t>
-            </a:r>
-            <a:endParaRPr lang="en-US" sz="1800" b="0" u="none" strike="noStrike">
-              <a:solidFill>
-                <a:srgbClr val="000000"/>
-              </a:solidFill>
-              <a:effectLst/>
-              <a:uFillTx/>
-              <a:latin typeface="Arial"/>
-            </a:endParaRPr>
-          </a:p>
-        </p:txBody>
-      </p:sp>
-      <p:sp>
-        <p:nvSpPr>
-          <p:cNvPr id="169" name="Text 11"/>
-          <p:cNvSpPr/>
-          <p:nvPr/>
-        </p:nvSpPr>
-        <p:spPr>
-          <a:xfrm>
-            <a:off x="3684960" y="8439120"/>
-            <a:ext cx="2715840" cy="533160"/>
-          </a:xfrm>
-          <a:prstGeom prst="rect">
-            <a:avLst/>
-          </a:prstGeom>
-          <a:noFill/>
-          <a:ln w="0">
-            <a:noFill/>
-          </a:ln>
-        </p:spPr>
-        <p:style>
-          <a:lnRef idx="0"/>
-          <a:fillRef idx="0"/>
-          <a:effectRef idx="0"/>
-          <a:fontRef idx="minor"/>
-        </p:style>
-        <p:txBody>
-          <a:bodyPr lIns="25560" tIns="25560" rIns="25560" bIns="25560" anchor="t">
-            <a:normAutofit fontScale="85000" lnSpcReduction="9999"/>
-          </a:bodyPr>
-          <a:p>
-            <a:pPr defTabSz="914400">
-              <a:lnSpc>
-                <a:spcPct val="100000"/>
-              </a:lnSpc>
-              <a:tabLst>
-                <a:tab pos="0" algn="l"/>
-              </a:tabLst>
-            </a:pPr>
-            <a:r>
-              <a:rPr lang="en-US" sz="3900" b="0" u="none" spc="-40" strike="noStrike">
-                <a:solidFill>
-                  <a:srgbClr val="1F2A24"/>
-                </a:solidFill>
-                <a:effectLst/>
-                <a:uFillTx/>
-                <a:latin typeface="Georgia"/>
-                <a:ea typeface="Georgia"/>
-              </a:rPr>
-              <a:t>Ray Ozzie</a:t>
-            </a:r>
-            <a:endParaRPr lang="en-US" sz="3900" b="0" u="none" strike="noStrike">
-              <a:solidFill>
-                <a:srgbClr val="000000"/>
-              </a:solidFill>
-              <a:effectLst/>
-              <a:uFillTx/>
-              <a:latin typeface="Arial"/>
-            </a:endParaRPr>
-          </a:p>
-        </p:txBody>
-      </p:sp>
-      <p:sp>
-        <p:nvSpPr>
-          <p:cNvPr id="170" name="Text 12"/>
-          <p:cNvSpPr/>
-          <p:nvPr/>
-        </p:nvSpPr>
-        <p:spPr>
-          <a:xfrm>
-            <a:off x="3684960" y="8934480"/>
-            <a:ext cx="2715840" cy="369360"/>
-          </a:xfrm>
-          <a:prstGeom prst="rect">
-            <a:avLst/>
-          </a:prstGeom>
-          <a:noFill/>
-          <a:ln w="0">
-            <a:noFill/>
-          </a:ln>
-        </p:spPr>
-        <p:style>
-          <a:lnRef idx="0"/>
-          <a:fillRef idx="0"/>
-          <a:effectRef idx="0"/>
-          <a:fontRef idx="minor"/>
-        </p:style>
-        <p:txBody>
-          <a:bodyPr lIns="25560" tIns="25560" rIns="25560" bIns="25560" anchor="t">
-            <a:normAutofit fontScale="70000" lnSpcReduction="19999"/>
-          </a:bodyPr>
-          <a:p>
-            <a:pPr defTabSz="914400">
-              <a:lnSpc>
-                <a:spcPct val="145000"/>
-              </a:lnSpc>
-              <a:tabLst>
-                <a:tab pos="0" algn="l"/>
-              </a:tabLst>
-            </a:pPr>
-            <a:r>
-              <a:rPr lang="en-US" sz="1800" b="0" u="none" strike="noStrike">
-                <a:solidFill>
-                  <a:srgbClr val="4C554F"/>
-                </a:solidFill>
-                <a:effectLst/>
-                <a:uFillTx/>
-                <a:latin typeface="Arial"/>
-                <a:ea typeface="Arial"/>
-              </a:rPr>
-              <a:t>Software pioneer · ex-Microsoft CSA</a:t>
-            </a:r>
-            <a:endParaRPr lang="en-US" sz="1800" b="0" u="none" strike="noStrike">
-              <a:solidFill>
-                <a:srgbClr val="000000"/>
-              </a:solidFill>
-              <a:effectLst/>
-              <a:uFillTx/>
-              <a:latin typeface="Arial"/>
-            </a:endParaRPr>
-          </a:p>
-        </p:txBody>
-      </p:sp>
-      <p:sp>
-        <p:nvSpPr>
-          <p:cNvPr id="171" name="Shape 13"/>
+          <p:cNvPr id="172" name="Shape 13"/>
           <p:cNvSpPr/>
           <p:nvPr/>
         </p:nvSpPr>
@@ -18926,7 +18998,7 @@
       </p:sp>
       <p:sp>
         <p:nvSpPr>
-          <p:cNvPr id="172" name="Text 14"/>
+          <p:cNvPr id="173" name="Text 14"/>
           <p:cNvSpPr/>
           <p:nvPr/>
         </p:nvSpPr>
@@ -18987,7 +19059,7 @@
       </p:sp>
       <p:sp>
         <p:nvSpPr>
-          <p:cNvPr id="173" name="Text 15"/>
+          <p:cNvPr id="174" name="Text 15"/>
           <p:cNvSpPr/>
           <p:nvPr/>
         </p:nvSpPr>
@@ -19178,7 +19250,7 @@
                 <a:latin typeface="Arial"/>
                 <a:ea typeface="Arial"/>
               </a:rPr>
-              <a:t>Advisory commitments: Joi Ito, Ray Ozzie, Takuo Dome</a:t>
+              <a:t>Advisory commitments: Joi Ito, Ray Ozzie</a:t>
             </a:r>
             <a:endParaRPr lang="en-US" sz="1800" b="0" u="none" strike="noStrike">
               <a:solidFill>
@@ -19193,14 +19265,14 @@
       </p:sp>
       <p:sp>
         <p:nvSpPr>
-          <p:cNvPr id="174" name="Shape 16"/>
+          <p:cNvPr id="175" name="Shape 16"/>
           <p:cNvSpPr/>
           <p:nvPr/>
         </p:nvSpPr>
         <p:spPr>
           <a:xfrm>
             <a:off x="9892440" y="4624560"/>
-            <a:ext cx="7347600" cy="2233440"/>
+            <a:ext cx="7347600" cy="2757600"/>
           </a:xfrm>
           <a:prstGeom prst="rect">
             <a:avLst/>
@@ -19239,7 +19311,7 @@
       </p:sp>
       <p:sp>
         <p:nvSpPr>
-          <p:cNvPr id="175" name="Text 17"/>
+          <p:cNvPr id="176" name="Text 17"/>
           <p:cNvSpPr/>
           <p:nvPr/>
         </p:nvSpPr>
@@ -19300,7 +19372,7 @@
       </p:sp>
       <p:sp>
         <p:nvSpPr>
-          <p:cNvPr id="176" name="Text 18"/>
+          <p:cNvPr id="177" name="Text 18"/>
           <p:cNvSpPr/>
           <p:nvPr/>
         </p:nvSpPr>
@@ -19507,14 +19579,14 @@
       </p:sp>
       <p:sp>
         <p:nvSpPr>
-          <p:cNvPr id="177" name="Shape 19"/>
-          <p:cNvSpPr/>
-          <p:nvPr/>
-        </p:nvSpPr>
-        <p:spPr>
-          <a:xfrm>
-            <a:off x="9892440" y="7086600"/>
-            <a:ext cx="7347600" cy="2057400"/>
+          <p:cNvPr id="178" name="Shape 19"/>
+          <p:cNvSpPr/>
+          <p:nvPr/>
+        </p:nvSpPr>
+        <p:spPr>
+          <a:xfrm>
+            <a:off x="9892440" y="7592040"/>
+            <a:ext cx="7347600" cy="2757600"/>
           </a:xfrm>
           <a:prstGeom prst="rect">
             <a:avLst/>
@@ -19553,13 +19625,13 @@
       </p:sp>
       <p:sp>
         <p:nvSpPr>
-          <p:cNvPr id="178" name="Text 20"/>
-          <p:cNvSpPr/>
-          <p:nvPr/>
-        </p:nvSpPr>
-        <p:spPr>
-          <a:xfrm>
-            <a:off x="10187640" y="7163280"/>
+          <p:cNvPr id="179" name="Text 20"/>
+          <p:cNvSpPr/>
+          <p:nvPr/>
+        </p:nvSpPr>
+        <p:spPr>
+          <a:xfrm>
+            <a:off x="10187640" y="7849080"/>
             <a:ext cx="6959880" cy="333000"/>
           </a:xfrm>
           <a:prstGeom prst="rect">
@@ -19614,13 +19686,13 @@
       </p:sp>
       <p:sp>
         <p:nvSpPr>
-          <p:cNvPr id="179" name="Text 21"/>
-          <p:cNvSpPr/>
-          <p:nvPr/>
-        </p:nvSpPr>
-        <p:spPr>
-          <a:xfrm>
-            <a:off x="10237320" y="7592040"/>
+          <p:cNvPr id="180" name="Text 21"/>
+          <p:cNvSpPr/>
+          <p:nvPr/>
+        </p:nvSpPr>
+        <p:spPr>
+          <a:xfrm>
+            <a:off x="10237320" y="8277840"/>
             <a:ext cx="6783840" cy="1375200"/>
           </a:xfrm>
           <a:prstGeom prst="rect">
@@ -19785,13 +19857,13 @@
       </p:sp>
       <p:sp>
         <p:nvSpPr>
-          <p:cNvPr id="180" name="Text 22"/>
-          <p:cNvSpPr/>
-          <p:nvPr/>
-        </p:nvSpPr>
-        <p:spPr>
-          <a:xfrm>
-            <a:off x="1143000" y="9266040"/>
+          <p:cNvPr id="181" name="Text 22"/>
+          <p:cNvSpPr/>
+          <p:nvPr/>
+        </p:nvSpPr>
+        <p:spPr>
+          <a:xfrm>
+            <a:off x="1047600" y="10350000"/>
             <a:ext cx="1154520" cy="304560"/>
           </a:xfrm>
           <a:prstGeom prst="rect">
@@ -19846,13 +19918,13 @@
       </p:sp>
       <p:sp>
         <p:nvSpPr>
-          <p:cNvPr id="181" name="Text 23"/>
-          <p:cNvSpPr/>
-          <p:nvPr/>
-        </p:nvSpPr>
-        <p:spPr>
-          <a:xfrm>
-            <a:off x="11620440" y="9296640"/>
+          <p:cNvPr id="182" name="Text 23"/>
+          <p:cNvSpPr/>
+          <p:nvPr/>
+        </p:nvSpPr>
+        <p:spPr>
+          <a:xfrm>
+            <a:off x="11654640" y="10350000"/>
             <a:ext cx="5753160" cy="304560"/>
           </a:xfrm>
           <a:prstGeom prst="rect">
@@ -19892,147 +19964,7 @@
                 <a:latin typeface="Courier New"/>
                 <a:ea typeface="Courier New"/>
               </a:rPr>
-              <a:t>PHASE 0 · MONTHS 01–03 · SELF-</a:t>
-            </a:r>
-            <a:r>
-              <a:rPr lang="en-US" sz="1800" b="0" u="none" spc="145" strike="noStrike">
-                <a:solidFill>
-                  <a:srgbClr val="4C554F"/>
-                </a:solidFill>
-                <a:effectLst/>
-                <a:uFillTx/>
-                <a:latin typeface="Courier New"/>
-                <a:ea typeface="Courier New"/>
-              </a:rPr>
-              <a:t>FUNDED</a:t>
-            </a:r>
-            <a:endParaRPr lang="en-US" sz="1800" b="0" u="none" strike="noStrike">
-              <a:solidFill>
-                <a:srgbClr val="000000"/>
-              </a:solidFill>
-              <a:effectLst/>
-              <a:uFillTx/>
-              <a:latin typeface="Arial"/>
-            </a:endParaRPr>
-          </a:p>
-        </p:txBody>
-      </p:sp>
-      <p:sp>
-        <p:nvSpPr>
-          <p:cNvPr id="182" name="Text 31"/>
-          <p:cNvSpPr/>
-          <p:nvPr/>
-        </p:nvSpPr>
-        <p:spPr>
-          <a:xfrm>
-            <a:off x="6656760" y="8458200"/>
-            <a:ext cx="2715840" cy="685800"/>
-          </a:xfrm>
-          <a:prstGeom prst="rect">
-            <a:avLst/>
-          </a:prstGeom>
-          <a:noFill/>
-          <a:ln w="0">
-            <a:noFill/>
-          </a:ln>
-        </p:spPr>
-        <p:style>
-          <a:lnRef idx="0"/>
-          <a:fillRef idx="0"/>
-          <a:effectRef idx="0"/>
-          <a:fontRef idx="minor"/>
-        </p:style>
-        <p:txBody>
-          <a:bodyPr lIns="25560" tIns="25560" rIns="25560" bIns="25560" anchor="t">
-            <a:normAutofit fontScale="92500" lnSpcReduction="9999"/>
-          </a:bodyPr>
-          <a:p>
-            <a:pPr defTabSz="914400">
-              <a:lnSpc>
-                <a:spcPct val="100000"/>
-              </a:lnSpc>
-              <a:tabLst>
-                <a:tab pos="0" algn="l"/>
-              </a:tabLst>
-            </a:pPr>
-            <a:r>
-              <a:rPr lang="en-US" sz="3900" b="0" u="none" spc="-40" strike="noStrike">
-                <a:solidFill>
-                  <a:srgbClr val="1F2A24"/>
-                </a:solidFill>
-                <a:effectLst/>
-                <a:uFillTx/>
-                <a:latin typeface="Georgia"/>
-                <a:ea typeface="Georgia"/>
-              </a:rPr>
-              <a:t>Takuo Dome</a:t>
-            </a:r>
-            <a:endParaRPr lang="en-US" sz="3900" b="0" u="none" strike="noStrike">
-              <a:solidFill>
-                <a:srgbClr val="000000"/>
-              </a:solidFill>
-              <a:effectLst/>
-              <a:uFillTx/>
-              <a:latin typeface="Arial"/>
-            </a:endParaRPr>
-          </a:p>
-        </p:txBody>
-      </p:sp>
-      <p:sp>
-        <p:nvSpPr>
-          <p:cNvPr id="183" name="Text 36"/>
-          <p:cNvSpPr/>
-          <p:nvPr/>
-        </p:nvSpPr>
-        <p:spPr>
-          <a:xfrm>
-            <a:off x="6629400" y="9015480"/>
-            <a:ext cx="2715840" cy="585720"/>
-          </a:xfrm>
-          <a:prstGeom prst="rect">
-            <a:avLst/>
-          </a:prstGeom>
-          <a:noFill/>
-          <a:ln w="0">
-            <a:noFill/>
-          </a:ln>
-        </p:spPr>
-        <p:style>
-          <a:lnRef idx="0"/>
-          <a:fillRef idx="0"/>
-          <a:effectRef idx="0"/>
-          <a:fontRef idx="minor"/>
-        </p:style>
-        <p:txBody>
-          <a:bodyPr lIns="25560" tIns="25560" rIns="25560" bIns="25560" anchor="t">
-            <a:normAutofit fontScale="62500" lnSpcReduction="19999"/>
-          </a:bodyPr>
-          <a:p>
-            <a:pPr defTabSz="914400">
-              <a:lnSpc>
-                <a:spcPct val="145000"/>
-              </a:lnSpc>
-              <a:spcBef>
-                <a:spcPts val="1191"/>
-              </a:spcBef>
-              <a:spcAft>
-                <a:spcPts val="992"/>
-              </a:spcAft>
-              <a:tabLst>
-                <a:tab pos="0" algn="l"/>
-              </a:tabLst>
-            </a:pPr>
-            <a:r>
-              <a:rPr lang="en-US" sz="1800" b="0" u="none" strike="noStrike">
-                <a:solidFill>
-                  <a:srgbClr val="4C554F"/>
-                </a:solidFill>
-                <a:effectLst/>
-                <a:uFillTx/>
-                <a:latin typeface="Arial"/>
-                <a:ea typeface="Arial"/>
-              </a:rPr>
-              <a:t>Professor Emeritus, Osaka University/ Representative Director, Inochi Forum</a:t>
+              <a:t>PHASE 0 · MONTHS 01–03 · SELF-FUNDED</a:t>
             </a:r>
             <a:endParaRPr lang="en-US" sz="1800" b="0" u="none" strike="noStrike">
               <a:solidFill>

</xml_diff>